<commit_message>
Update Day 5 folder with latest files
</commit_message>
<xml_diff>
--- a/Day 5/Day5_Self_Study.pptx
+++ b/Day 5/Day5_Self_Study.pptx
@@ -5,7 +5,7 @@
     <p:sldMasterId id="2147483648" r:id="rId1"/>
   </p:sldMasterIdLst>
   <p:notesMasterIdLst>
-    <p:notesMasterId r:id="rId19"/>
+    <p:notesMasterId r:id="rId17"/>
   </p:notesMasterIdLst>
   <p:sldIdLst>
     <p:sldId id="256" r:id="rId2"/>
@@ -16,15 +16,13 @@
     <p:sldId id="262" r:id="rId7"/>
     <p:sldId id="263" r:id="rId8"/>
     <p:sldId id="265" r:id="rId9"/>
-    <p:sldId id="261" r:id="rId10"/>
-    <p:sldId id="264" r:id="rId11"/>
-    <p:sldId id="266" r:id="rId12"/>
-    <p:sldId id="267" r:id="rId13"/>
-    <p:sldId id="268" r:id="rId14"/>
-    <p:sldId id="269" r:id="rId15"/>
-    <p:sldId id="270" r:id="rId16"/>
-    <p:sldId id="271" r:id="rId17"/>
-    <p:sldId id="272" r:id="rId18"/>
+    <p:sldId id="266" r:id="rId10"/>
+    <p:sldId id="267" r:id="rId11"/>
+    <p:sldId id="268" r:id="rId12"/>
+    <p:sldId id="269" r:id="rId13"/>
+    <p:sldId id="270" r:id="rId14"/>
+    <p:sldId id="271" r:id="rId15"/>
+    <p:sldId id="272" r:id="rId16"/>
   </p:sldIdLst>
   <p:sldSz cx="12192000" cy="6858000"/>
   <p:notesSz cx="6858000" cy="12192000"/>
@@ -826,174 +824,6 @@
             <a:fld id="{F7021451-1387-4CA6-816F-3879F97B5CBC}" type="slidenum">
               <a:rPr lang="en-US"/>
               <a:t>15</a:t>
-            </a:fld>
-            <a:endParaRPr lang="en-US"/>
-          </a:p>
-        </p:txBody>
-      </p:sp>
-    </p:spTree>
-    <p:extLst>
-      <p:ext uri="{BB962C8B-B14F-4D97-AF65-F5344CB8AC3E}">
-        <p14:creationId xmlns:p14="http://schemas.microsoft.com/office/powerpoint/2010/main" val="1024086991"/>
-      </p:ext>
-    </p:extLst>
-  </p:cSld>
-  <p:clrMapOvr>
-    <a:masterClrMapping/>
-  </p:clrMapOvr>
-</p:notes>
-</file>
-
-<file path=ppt/notesSlides/notesSlide16.xml><?xml version="1.0" encoding="utf-8"?>
-<p:notes xmlns:a="http://schemas.openxmlformats.org/drawingml/2006/main" xmlns:r="http://schemas.openxmlformats.org/officeDocument/2006/relationships" xmlns:p="http://schemas.openxmlformats.org/presentationml/2006/main">
-  <p:cSld>
-    <p:spTree>
-      <p:nvGrpSpPr>
-        <p:cNvPr id="1" name=""/>
-        <p:cNvGrpSpPr/>
-        <p:nvPr/>
-      </p:nvGrpSpPr>
-      <p:grpSpPr>
-        <a:xfrm>
-          <a:off x="0" y="0"/>
-          <a:ext cx="0" cy="0"/>
-          <a:chOff x="0" y="0"/>
-          <a:chExt cx="0" cy="0"/>
-        </a:xfrm>
-      </p:grpSpPr>
-      <p:sp>
-        <p:nvSpPr>
-          <p:cNvPr id="2" name="Slide Image Placeholder 1"/>
-          <p:cNvSpPr>
-            <a:spLocks noGrp="1" noRot="1" noChangeAspect="1"/>
-          </p:cNvSpPr>
-          <p:nvPr>
-            <p:ph type="sldImg"/>
-          </p:nvPr>
-        </p:nvSpPr>
-        <p:spPr/>
-      </p:sp>
-      <p:sp>
-        <p:nvSpPr>
-          <p:cNvPr id="3" name="Notes Placeholder 2"/>
-          <p:cNvSpPr>
-            <a:spLocks noGrp="1"/>
-          </p:cNvSpPr>
-          <p:nvPr>
-            <p:ph type="body" idx="1"/>
-          </p:nvPr>
-        </p:nvSpPr>
-        <p:spPr/>
-        <p:txBody>
-          <a:bodyPr/>
-          <a:lstStyle/>
-          <a:p>
-            <a:endParaRPr lang="en-US" dirty="0"/>
-          </a:p>
-        </p:txBody>
-      </p:sp>
-      <p:sp>
-        <p:nvSpPr>
-          <p:cNvPr id="4" name="Slide Number Placeholder 3"/>
-          <p:cNvSpPr>
-            <a:spLocks noGrp="1"/>
-          </p:cNvSpPr>
-          <p:nvPr>
-            <p:ph type="sldNum" sz="quarter" idx="10"/>
-          </p:nvPr>
-        </p:nvSpPr>
-        <p:spPr/>
-        <p:txBody>
-          <a:bodyPr/>
-          <a:lstStyle/>
-          <a:p>
-            <a:fld id="{F7021451-1387-4CA6-816F-3879F97B5CBC}" type="slidenum">
-              <a:rPr lang="en-US"/>
-              <a:t>16</a:t>
-            </a:fld>
-            <a:endParaRPr lang="en-US"/>
-          </a:p>
-        </p:txBody>
-      </p:sp>
-    </p:spTree>
-    <p:extLst>
-      <p:ext uri="{BB962C8B-B14F-4D97-AF65-F5344CB8AC3E}">
-        <p14:creationId xmlns:p14="http://schemas.microsoft.com/office/powerpoint/2010/main" val="1024086991"/>
-      </p:ext>
-    </p:extLst>
-  </p:cSld>
-  <p:clrMapOvr>
-    <a:masterClrMapping/>
-  </p:clrMapOvr>
-</p:notes>
-</file>
-
-<file path=ppt/notesSlides/notesSlide17.xml><?xml version="1.0" encoding="utf-8"?>
-<p:notes xmlns:a="http://schemas.openxmlformats.org/drawingml/2006/main" xmlns:r="http://schemas.openxmlformats.org/officeDocument/2006/relationships" xmlns:p="http://schemas.openxmlformats.org/presentationml/2006/main">
-  <p:cSld>
-    <p:spTree>
-      <p:nvGrpSpPr>
-        <p:cNvPr id="1" name=""/>
-        <p:cNvGrpSpPr/>
-        <p:nvPr/>
-      </p:nvGrpSpPr>
-      <p:grpSpPr>
-        <a:xfrm>
-          <a:off x="0" y="0"/>
-          <a:ext cx="0" cy="0"/>
-          <a:chOff x="0" y="0"/>
-          <a:chExt cx="0" cy="0"/>
-        </a:xfrm>
-      </p:grpSpPr>
-      <p:sp>
-        <p:nvSpPr>
-          <p:cNvPr id="2" name="Slide Image Placeholder 1"/>
-          <p:cNvSpPr>
-            <a:spLocks noGrp="1" noRot="1" noChangeAspect="1"/>
-          </p:cNvSpPr>
-          <p:nvPr>
-            <p:ph type="sldImg"/>
-          </p:nvPr>
-        </p:nvSpPr>
-        <p:spPr/>
-      </p:sp>
-      <p:sp>
-        <p:nvSpPr>
-          <p:cNvPr id="3" name="Notes Placeholder 2"/>
-          <p:cNvSpPr>
-            <a:spLocks noGrp="1"/>
-          </p:cNvSpPr>
-          <p:nvPr>
-            <p:ph type="body" idx="1"/>
-          </p:nvPr>
-        </p:nvSpPr>
-        <p:spPr/>
-        <p:txBody>
-          <a:bodyPr/>
-          <a:lstStyle/>
-          <a:p>
-            <a:endParaRPr lang="en-US" dirty="0"/>
-          </a:p>
-        </p:txBody>
-      </p:sp>
-      <p:sp>
-        <p:nvSpPr>
-          <p:cNvPr id="4" name="Slide Number Placeholder 3"/>
-          <p:cNvSpPr>
-            <a:spLocks noGrp="1"/>
-          </p:cNvSpPr>
-          <p:nvPr>
-            <p:ph type="sldNum" sz="quarter" idx="10"/>
-          </p:nvPr>
-        </p:nvSpPr>
-        <p:spPr/>
-        <p:txBody>
-          <a:bodyPr/>
-          <a:lstStyle/>
-          <a:p>
-            <a:fld id="{F7021451-1387-4CA6-816F-3879F97B5CBC}" type="slidenum">
-              <a:rPr lang="en-US"/>
-              <a:t>17</a:t>
             </a:fld>
             <a:endParaRPr lang="en-US"/>
           </a:p>
@@ -2409,1437 +2239,6 @@
 </file>
 
 <file path=ppt/slides/slide10.xml><?xml version="1.0" encoding="utf-8"?>
-<p:sld xmlns:a="http://schemas.openxmlformats.org/drawingml/2006/main" xmlns:r="http://schemas.openxmlformats.org/officeDocument/2006/relationships" xmlns:p="http://schemas.openxmlformats.org/presentationml/2006/main">
-  <p:cSld name="Slide 9">
-    <p:bg>
-      <p:bgPr>
-        <a:solidFill>
-          <a:srgbClr val="FFFFFF"/>
-        </a:solidFill>
-        <a:effectLst/>
-      </p:bgPr>
-    </p:bg>
-    <p:spTree>
-      <p:nvGrpSpPr>
-        <p:cNvPr id="1" name=""/>
-        <p:cNvGrpSpPr/>
-        <p:nvPr/>
-      </p:nvGrpSpPr>
-      <p:grpSpPr>
-        <a:xfrm>
-          <a:off x="0" y="0"/>
-          <a:ext cx="0" cy="0"/>
-          <a:chOff x="0" y="0"/>
-          <a:chExt cx="0" cy="0"/>
-        </a:xfrm>
-      </p:grpSpPr>
-      <p:sp>
-        <p:nvSpPr>
-          <p:cNvPr id="2" name="Shape 0"/>
-          <p:cNvSpPr/>
-          <p:nvPr/>
-        </p:nvSpPr>
-        <p:spPr>
-          <a:xfrm>
-            <a:off x="548640" y="457200"/>
-            <a:ext cx="3108960" cy="347472"/>
-          </a:xfrm>
-          <a:prstGeom prst="roundRect">
-            <a:avLst>
-              <a:gd name="adj" fmla="val 21053"/>
-            </a:avLst>
-          </a:prstGeom>
-          <a:solidFill>
-            <a:srgbClr val="FCEEDA"/>
-          </a:solidFill>
-          <a:ln/>
-        </p:spPr>
-        <p:txBody>
-          <a:bodyPr/>
-          <a:lstStyle/>
-          <a:p>
-            <a:endParaRPr/>
-          </a:p>
-        </p:txBody>
-      </p:sp>
-      <p:sp>
-        <p:nvSpPr>
-          <p:cNvPr id="3" name="Text 1"/>
-          <p:cNvSpPr/>
-          <p:nvPr/>
-        </p:nvSpPr>
-        <p:spPr>
-          <a:xfrm>
-            <a:off x="548640" y="457200"/>
-            <a:ext cx="3108960" cy="347472"/>
-          </a:xfrm>
-          <a:prstGeom prst="rect">
-            <a:avLst/>
-          </a:prstGeom>
-          <a:noFill/>
-          <a:ln/>
-        </p:spPr>
-        <p:txBody>
-          <a:bodyPr wrap="square" lIns="0" tIns="0" rIns="0" bIns="0" rtlCol="0" anchor="ctr"/>
-          <a:lstStyle/>
-          <a:p>
-            <a:pPr marL="0" indent="0" algn="ctr">
-              <a:buNone/>
-            </a:pPr>
-            <a:r>
-              <a:rPr lang="en-US" sz="1200" b="1" dirty="0">
-                <a:solidFill>
-                  <a:srgbClr val="E8912B"/>
-                </a:solidFill>
-                <a:latin typeface="Calibri" pitchFamily="34" charset="0"/>
-                <a:ea typeface="Calibri" pitchFamily="34" charset="-122"/>
-                <a:cs typeface="Calibri" pitchFamily="34" charset="-120"/>
-              </a:rPr>
-              <a:t>QUICK PRACTICE · ROUND 2</a:t>
-            </a:r>
-            <a:endParaRPr lang="en-US" sz="1200" dirty="0"/>
-          </a:p>
-        </p:txBody>
-      </p:sp>
-      <p:sp>
-        <p:nvSpPr>
-          <p:cNvPr id="4" name="Text 2"/>
-          <p:cNvSpPr/>
-          <p:nvPr/>
-        </p:nvSpPr>
-        <p:spPr>
-          <a:xfrm>
-            <a:off x="548640" y="960120"/>
-            <a:ext cx="11091672" cy="731520"/>
-          </a:xfrm>
-          <a:prstGeom prst="rect">
-            <a:avLst/>
-          </a:prstGeom>
-          <a:noFill/>
-          <a:ln/>
-        </p:spPr>
-        <p:txBody>
-          <a:bodyPr wrap="square" lIns="0" tIns="0" rIns="0" bIns="0" rtlCol="0" anchor="ctr"/>
-          <a:lstStyle/>
-          <a:p>
-            <a:pPr marL="0" indent="0">
-              <a:buNone/>
-            </a:pPr>
-            <a:r>
-              <a:rPr lang="en-US" sz="2800" b="1" dirty="0">
-                <a:solidFill>
-                  <a:srgbClr val="1E2761"/>
-                </a:solidFill>
-                <a:latin typeface="Calibri" pitchFamily="34" charset="0"/>
-                <a:ea typeface="Calibri" pitchFamily="34" charset="-122"/>
-                <a:cs typeface="Calibri" pitchFamily="34" charset="-120"/>
-              </a:rPr>
-              <a:t>Try It Yourself: Stats Warm-Up</a:t>
-            </a:r>
-            <a:endParaRPr lang="en-US" sz="2800" dirty="0"/>
-          </a:p>
-        </p:txBody>
-      </p:sp>
-      <p:sp>
-        <p:nvSpPr>
-          <p:cNvPr id="5" name="Text 3"/>
-          <p:cNvSpPr/>
-          <p:nvPr/>
-        </p:nvSpPr>
-        <p:spPr>
-          <a:xfrm>
-            <a:off x="548640" y="1600200"/>
-            <a:ext cx="9692640" cy="365760"/>
-          </a:xfrm>
-          <a:prstGeom prst="rect">
-            <a:avLst/>
-          </a:prstGeom>
-          <a:noFill/>
-          <a:ln/>
-        </p:spPr>
-        <p:txBody>
-          <a:bodyPr wrap="square" lIns="0" tIns="0" rIns="0" bIns="0" rtlCol="0" anchor="ctr"/>
-          <a:lstStyle/>
-          <a:p>
-            <a:pPr marL="0" indent="0">
-              <a:buNone/>
-            </a:pPr>
-            <a:r>
-              <a:rPr lang="en-US" sz="1400" dirty="0">
-                <a:solidFill>
-                  <a:srgbClr val="6B6B6B"/>
-                </a:solidFill>
-                <a:latin typeface="Calibri" pitchFamily="34" charset="0"/>
-                <a:ea typeface="Calibri" pitchFamily="34" charset="-122"/>
-                <a:cs typeface="Calibri" pitchFamily="34" charset="-120"/>
-              </a:rPr>
-              <a:t>Work through this on your own, at your own pace — no need to wait for anyone.</a:t>
-            </a:r>
-            <a:endParaRPr lang="en-US" sz="1400" dirty="0"/>
-          </a:p>
-        </p:txBody>
-      </p:sp>
-      <p:sp>
-        <p:nvSpPr>
-          <p:cNvPr id="6" name="Shape 4"/>
-          <p:cNvSpPr/>
-          <p:nvPr/>
-        </p:nvSpPr>
-        <p:spPr>
-          <a:xfrm>
-            <a:off x="548640" y="2103120"/>
-            <a:ext cx="1371600" cy="457200"/>
-          </a:xfrm>
-          <a:prstGeom prst="roundRect">
-            <a:avLst>
-              <a:gd name="adj" fmla="val 50000"/>
-            </a:avLst>
-          </a:prstGeom>
-          <a:solidFill>
-            <a:srgbClr val="DADBF1"/>
-          </a:solidFill>
-          <a:ln/>
-        </p:spPr>
-        <p:txBody>
-          <a:bodyPr/>
-          <a:lstStyle/>
-          <a:p>
-            <a:endParaRPr/>
-          </a:p>
-        </p:txBody>
-      </p:sp>
-      <p:sp>
-        <p:nvSpPr>
-          <p:cNvPr id="7" name="Text 5"/>
-          <p:cNvSpPr/>
-          <p:nvPr/>
-        </p:nvSpPr>
-        <p:spPr>
-          <a:xfrm>
-            <a:off x="548640" y="2103120"/>
-            <a:ext cx="1371600" cy="457200"/>
-          </a:xfrm>
-          <a:prstGeom prst="rect">
-            <a:avLst/>
-          </a:prstGeom>
-          <a:noFill/>
-          <a:ln/>
-        </p:spPr>
-        <p:txBody>
-          <a:bodyPr wrap="square" lIns="0" tIns="0" rIns="0" bIns="0" rtlCol="0" anchor="ctr"/>
-          <a:lstStyle/>
-          <a:p>
-            <a:pPr marL="0" indent="0" algn="ctr">
-              <a:buNone/>
-            </a:pPr>
-            <a:r>
-              <a:rPr lang="en-US" sz="1200" b="1" dirty="0">
-                <a:solidFill>
-                  <a:srgbClr val="4950BC"/>
-                </a:solidFill>
-                <a:latin typeface="Calibri" pitchFamily="34" charset="0"/>
-                <a:ea typeface="Calibri" pitchFamily="34" charset="-122"/>
-                <a:cs typeface="Calibri" pitchFamily="34" charset="-120"/>
-              </a:rPr>
-              <a:t>⏱  5 min</a:t>
-            </a:r>
-            <a:endParaRPr lang="en-US" sz="1200" dirty="0"/>
-          </a:p>
-        </p:txBody>
-      </p:sp>
-      <p:sp>
-        <p:nvSpPr>
-          <p:cNvPr id="8" name="Text 6"/>
-          <p:cNvSpPr/>
-          <p:nvPr/>
-        </p:nvSpPr>
-        <p:spPr>
-          <a:xfrm>
-            <a:off x="2103120" y="2103120"/>
-            <a:ext cx="8686800" cy="457200"/>
-          </a:xfrm>
-          <a:prstGeom prst="rect">
-            <a:avLst/>
-          </a:prstGeom>
-          <a:noFill/>
-          <a:ln/>
-        </p:spPr>
-        <p:txBody>
-          <a:bodyPr wrap="square" lIns="0" tIns="0" rIns="0" bIns="0" rtlCol="0" anchor="ctr"/>
-          <a:lstStyle/>
-          <a:p>
-            <a:pPr marL="0" indent="0">
-              <a:buNone/>
-            </a:pPr>
-            <a:r>
-              <a:rPr lang="en-US" sz="1400" b="1" dirty="0">
-                <a:solidFill>
-                  <a:srgbClr val="272525"/>
-                </a:solidFill>
-                <a:latin typeface="Calibri" pitchFamily="34" charset="0"/>
-                <a:ea typeface="Calibri" pitchFamily="34" charset="-122"/>
-                <a:cs typeface="Calibri" pitchFamily="34" charset="-120"/>
-              </a:rPr>
-              <a:t>Task:  </a:t>
-            </a:r>
-            <a:r>
-              <a:rPr lang="en-US" sz="1400" dirty="0">
-                <a:solidFill>
-                  <a:srgbClr val="272525"/>
-                </a:solidFill>
-                <a:latin typeface="Calibri" pitchFamily="34" charset="0"/>
-                <a:ea typeface="Calibri" pitchFamily="34" charset="-122"/>
-                <a:cs typeface="Calibri" pitchFamily="34" charset="-120"/>
-              </a:rPr>
-              <a:t>Compute summary stats on your Round 1 array.</a:t>
-            </a:r>
-            <a:endParaRPr lang="en-US" sz="1400" dirty="0"/>
-          </a:p>
-        </p:txBody>
-      </p:sp>
-      <p:sp>
-        <p:nvSpPr>
-          <p:cNvPr id="9" name="Shape 7"/>
-          <p:cNvSpPr/>
-          <p:nvPr/>
-        </p:nvSpPr>
-        <p:spPr>
-          <a:xfrm>
-            <a:off x="548640" y="2834640"/>
-            <a:ext cx="365760" cy="365760"/>
-          </a:xfrm>
-          <a:prstGeom prst="ellipse">
-            <a:avLst/>
-          </a:prstGeom>
-          <a:solidFill>
-            <a:srgbClr val="E8912B"/>
-          </a:solidFill>
-          <a:ln/>
-        </p:spPr>
-        <p:txBody>
-          <a:bodyPr/>
-          <a:lstStyle/>
-          <a:p>
-            <a:endParaRPr/>
-          </a:p>
-        </p:txBody>
-      </p:sp>
-      <p:sp>
-        <p:nvSpPr>
-          <p:cNvPr id="10" name="Text 8"/>
-          <p:cNvSpPr/>
-          <p:nvPr/>
-        </p:nvSpPr>
-        <p:spPr>
-          <a:xfrm>
-            <a:off x="548640" y="2834640"/>
-            <a:ext cx="365760" cy="365760"/>
-          </a:xfrm>
-          <a:prstGeom prst="rect">
-            <a:avLst/>
-          </a:prstGeom>
-          <a:noFill/>
-          <a:ln/>
-        </p:spPr>
-        <p:txBody>
-          <a:bodyPr wrap="square" lIns="0" tIns="0" rIns="0" bIns="0" rtlCol="0" anchor="ctr"/>
-          <a:lstStyle/>
-          <a:p>
-            <a:pPr marL="0" indent="0" algn="ctr">
-              <a:buNone/>
-            </a:pPr>
-            <a:r>
-              <a:rPr lang="en-US" sz="1300" b="1" dirty="0">
-                <a:solidFill>
-                  <a:srgbClr val="FFFFFF"/>
-                </a:solidFill>
-                <a:latin typeface="Calibri" pitchFamily="34" charset="0"/>
-                <a:ea typeface="Calibri" pitchFamily="34" charset="-122"/>
-                <a:cs typeface="Calibri" pitchFamily="34" charset="-120"/>
-              </a:rPr>
-              <a:t>1</a:t>
-            </a:r>
-            <a:endParaRPr lang="en-US" sz="1300" dirty="0"/>
-          </a:p>
-        </p:txBody>
-      </p:sp>
-      <p:sp>
-        <p:nvSpPr>
-          <p:cNvPr id="11" name="Text 9"/>
-          <p:cNvSpPr/>
-          <p:nvPr/>
-        </p:nvSpPr>
-        <p:spPr>
-          <a:xfrm>
-            <a:off x="1097280" y="2788920"/>
-            <a:ext cx="10241280" cy="502920"/>
-          </a:xfrm>
-          <a:prstGeom prst="rect">
-            <a:avLst/>
-          </a:prstGeom>
-          <a:noFill/>
-          <a:ln/>
-        </p:spPr>
-        <p:txBody>
-          <a:bodyPr wrap="square" lIns="0" tIns="0" rIns="0" bIns="0" rtlCol="0" anchor="t"/>
-          <a:lstStyle/>
-          <a:p>
-            <a:pPr marL="0" indent="0">
-              <a:buNone/>
-            </a:pPr>
-            <a:r>
-              <a:rPr lang="en-US" sz="1300" dirty="0">
-                <a:solidFill>
-                  <a:srgbClr val="272525"/>
-                </a:solidFill>
-                <a:latin typeface="Calibri" pitchFamily="34" charset="0"/>
-                <a:ea typeface="Calibri" pitchFamily="34" charset="-122"/>
-                <a:cs typeface="Calibri" pitchFamily="34" charset="-120"/>
-              </a:rPr>
-              <a:t>Reuse the array from array_warmup.py (or make a new one with 6+ numbers).</a:t>
-            </a:r>
-            <a:endParaRPr lang="en-US" sz="1300" dirty="0"/>
-          </a:p>
-        </p:txBody>
-      </p:sp>
-      <p:sp>
-        <p:nvSpPr>
-          <p:cNvPr id="12" name="Shape 10"/>
-          <p:cNvSpPr/>
-          <p:nvPr/>
-        </p:nvSpPr>
-        <p:spPr>
-          <a:xfrm>
-            <a:off x="548640" y="3401568"/>
-            <a:ext cx="365760" cy="365760"/>
-          </a:xfrm>
-          <a:prstGeom prst="ellipse">
-            <a:avLst/>
-          </a:prstGeom>
-          <a:solidFill>
-            <a:srgbClr val="E8912B"/>
-          </a:solidFill>
-          <a:ln/>
-        </p:spPr>
-        <p:txBody>
-          <a:bodyPr/>
-          <a:lstStyle/>
-          <a:p>
-            <a:endParaRPr/>
-          </a:p>
-        </p:txBody>
-      </p:sp>
-      <p:sp>
-        <p:nvSpPr>
-          <p:cNvPr id="13" name="Text 11"/>
-          <p:cNvSpPr/>
-          <p:nvPr/>
-        </p:nvSpPr>
-        <p:spPr>
-          <a:xfrm>
-            <a:off x="548640" y="3401568"/>
-            <a:ext cx="365760" cy="365760"/>
-          </a:xfrm>
-          <a:prstGeom prst="rect">
-            <a:avLst/>
-          </a:prstGeom>
-          <a:noFill/>
-          <a:ln/>
-        </p:spPr>
-        <p:txBody>
-          <a:bodyPr wrap="square" lIns="0" tIns="0" rIns="0" bIns="0" rtlCol="0" anchor="ctr"/>
-          <a:lstStyle/>
-          <a:p>
-            <a:pPr marL="0" indent="0" algn="ctr">
-              <a:buNone/>
-            </a:pPr>
-            <a:r>
-              <a:rPr lang="en-US" sz="1300" b="1" dirty="0">
-                <a:solidFill>
-                  <a:srgbClr val="FFFFFF"/>
-                </a:solidFill>
-                <a:latin typeface="Calibri" pitchFamily="34" charset="0"/>
-                <a:ea typeface="Calibri" pitchFamily="34" charset="-122"/>
-                <a:cs typeface="Calibri" pitchFamily="34" charset="-120"/>
-              </a:rPr>
-              <a:t>2</a:t>
-            </a:r>
-            <a:endParaRPr lang="en-US" sz="1300" dirty="0"/>
-          </a:p>
-        </p:txBody>
-      </p:sp>
-      <p:sp>
-        <p:nvSpPr>
-          <p:cNvPr id="14" name="Text 12"/>
-          <p:cNvSpPr/>
-          <p:nvPr/>
-        </p:nvSpPr>
-        <p:spPr>
-          <a:xfrm>
-            <a:off x="1097280" y="3355848"/>
-            <a:ext cx="10241280" cy="502920"/>
-          </a:xfrm>
-          <a:prstGeom prst="rect">
-            <a:avLst/>
-          </a:prstGeom>
-          <a:noFill/>
-          <a:ln/>
-        </p:spPr>
-        <p:txBody>
-          <a:bodyPr wrap="square" lIns="0" tIns="0" rIns="0" bIns="0" rtlCol="0" anchor="t"/>
-          <a:lstStyle/>
-          <a:p>
-            <a:pPr marL="0" indent="0">
-              <a:buNone/>
-            </a:pPr>
-            <a:r>
-              <a:rPr lang="en-US" sz="1300" dirty="0">
-                <a:solidFill>
-                  <a:srgbClr val="272525"/>
-                </a:solidFill>
-                <a:latin typeface="Calibri" pitchFamily="34" charset="0"/>
-                <a:ea typeface="Calibri" pitchFamily="34" charset="-122"/>
-                <a:cs typeface="Calibri" pitchFamily="34" charset="-120"/>
-              </a:rPr>
-              <a:t>Print mean(), max(), min(), and sum().</a:t>
-            </a:r>
-            <a:endParaRPr lang="en-US" sz="1300" dirty="0"/>
-          </a:p>
-        </p:txBody>
-      </p:sp>
-      <p:sp>
-        <p:nvSpPr>
-          <p:cNvPr id="15" name="Shape 13"/>
-          <p:cNvSpPr/>
-          <p:nvPr/>
-        </p:nvSpPr>
-        <p:spPr>
-          <a:xfrm>
-            <a:off x="548640" y="3968496"/>
-            <a:ext cx="365760" cy="365760"/>
-          </a:xfrm>
-          <a:prstGeom prst="ellipse">
-            <a:avLst/>
-          </a:prstGeom>
-          <a:solidFill>
-            <a:srgbClr val="E8912B"/>
-          </a:solidFill>
-          <a:ln/>
-        </p:spPr>
-        <p:txBody>
-          <a:bodyPr/>
-          <a:lstStyle/>
-          <a:p>
-            <a:endParaRPr/>
-          </a:p>
-        </p:txBody>
-      </p:sp>
-      <p:sp>
-        <p:nvSpPr>
-          <p:cNvPr id="16" name="Text 14"/>
-          <p:cNvSpPr/>
-          <p:nvPr/>
-        </p:nvSpPr>
-        <p:spPr>
-          <a:xfrm>
-            <a:off x="548640" y="3968496"/>
-            <a:ext cx="365760" cy="365760"/>
-          </a:xfrm>
-          <a:prstGeom prst="rect">
-            <a:avLst/>
-          </a:prstGeom>
-          <a:noFill/>
-          <a:ln/>
-        </p:spPr>
-        <p:txBody>
-          <a:bodyPr wrap="square" lIns="0" tIns="0" rIns="0" bIns="0" rtlCol="0" anchor="ctr"/>
-          <a:lstStyle/>
-          <a:p>
-            <a:pPr marL="0" indent="0" algn="ctr">
-              <a:buNone/>
-            </a:pPr>
-            <a:r>
-              <a:rPr lang="en-US" sz="1300" b="1" dirty="0">
-                <a:solidFill>
-                  <a:srgbClr val="FFFFFF"/>
-                </a:solidFill>
-                <a:latin typeface="Calibri" pitchFamily="34" charset="0"/>
-                <a:ea typeface="Calibri" pitchFamily="34" charset="-122"/>
-                <a:cs typeface="Calibri" pitchFamily="34" charset="-120"/>
-              </a:rPr>
-              <a:t>3</a:t>
-            </a:r>
-            <a:endParaRPr lang="en-US" sz="1300" dirty="0"/>
-          </a:p>
-        </p:txBody>
-      </p:sp>
-      <p:sp>
-        <p:nvSpPr>
-          <p:cNvPr id="17" name="Text 15"/>
-          <p:cNvSpPr/>
-          <p:nvPr/>
-        </p:nvSpPr>
-        <p:spPr>
-          <a:xfrm>
-            <a:off x="1097280" y="3922776"/>
-            <a:ext cx="10241280" cy="502920"/>
-          </a:xfrm>
-          <a:prstGeom prst="rect">
-            <a:avLst/>
-          </a:prstGeom>
-          <a:noFill/>
-          <a:ln/>
-        </p:spPr>
-        <p:txBody>
-          <a:bodyPr wrap="square" lIns="0" tIns="0" rIns="0" bIns="0" rtlCol="0" anchor="t"/>
-          <a:lstStyle/>
-          <a:p>
-            <a:pPr marL="0" indent="0">
-              <a:buNone/>
-            </a:pPr>
-            <a:r>
-              <a:rPr lang="en-US" sz="1300" dirty="0">
-                <a:solidFill>
-                  <a:srgbClr val="272525"/>
-                </a:solidFill>
-                <a:latin typeface="Calibri" pitchFamily="34" charset="0"/>
-                <a:ea typeface="Calibri" pitchFamily="34" charset="-122"/>
-                <a:cs typeface="Calibri" pitchFamily="34" charset="-120"/>
-              </a:rPr>
-              <a:t>Use a boolean condition to print how many values are above the mean.</a:t>
-            </a:r>
-            <a:endParaRPr lang="en-US" sz="1300" dirty="0"/>
-          </a:p>
-        </p:txBody>
-      </p:sp>
-      <p:sp>
-        <p:nvSpPr>
-          <p:cNvPr id="18" name="Shape 16"/>
-          <p:cNvSpPr/>
-          <p:nvPr/>
-        </p:nvSpPr>
-        <p:spPr>
-          <a:xfrm>
-            <a:off x="548640" y="4764024"/>
-            <a:ext cx="11091672" cy="731520"/>
-          </a:xfrm>
-          <a:prstGeom prst="roundRect">
-            <a:avLst>
-              <a:gd name="adj" fmla="val 10000"/>
-            </a:avLst>
-          </a:prstGeom>
-          <a:solidFill>
-            <a:srgbClr val="F5F5F7"/>
-          </a:solidFill>
-          <a:ln/>
-        </p:spPr>
-        <p:txBody>
-          <a:bodyPr/>
-          <a:lstStyle/>
-          <a:p>
-            <a:endParaRPr/>
-          </a:p>
-        </p:txBody>
-      </p:sp>
-      <p:sp>
-        <p:nvSpPr>
-          <p:cNvPr id="19" name="Text 17"/>
-          <p:cNvSpPr/>
-          <p:nvPr/>
-        </p:nvSpPr>
-        <p:spPr>
-          <a:xfrm>
-            <a:off x="822960" y="4764024"/>
-            <a:ext cx="10543032" cy="731520"/>
-          </a:xfrm>
-          <a:prstGeom prst="rect">
-            <a:avLst/>
-          </a:prstGeom>
-          <a:noFill/>
-          <a:ln/>
-        </p:spPr>
-        <p:txBody>
-          <a:bodyPr wrap="square" lIns="0" tIns="0" rIns="0" bIns="0" rtlCol="0" anchor="ctr"/>
-          <a:lstStyle/>
-          <a:p>
-            <a:pPr marL="0" indent="0">
-              <a:buNone/>
-            </a:pPr>
-            <a:r>
-              <a:rPr lang="en-US" sz="1250" b="1" dirty="0">
-                <a:solidFill>
-                  <a:srgbClr val="272525"/>
-                </a:solidFill>
-                <a:latin typeface="Calibri" pitchFamily="34" charset="0"/>
-                <a:ea typeface="Calibri" pitchFamily="34" charset="-122"/>
-                <a:cs typeface="Calibri" pitchFamily="34" charset="-120"/>
-              </a:rPr>
-              <a:t>💡 Hint:  </a:t>
-            </a:r>
-            <a:r>
-              <a:rPr lang="en-US" sz="1250" dirty="0">
-                <a:solidFill>
-                  <a:srgbClr val="6B6B6B"/>
-                </a:solidFill>
-                <a:latin typeface="Calibri" pitchFamily="34" charset="0"/>
-                <a:ea typeface="Calibri" pitchFamily="34" charset="-122"/>
-                <a:cs typeface="Calibri" pitchFamily="34" charset="-120"/>
-              </a:rPr>
-              <a:t>arr &gt; arr.mean() gives you True/False for every item — np.sum() on that counts the Trues.</a:t>
-            </a:r>
-            <a:endParaRPr lang="en-US" sz="1250" dirty="0"/>
-          </a:p>
-        </p:txBody>
-      </p:sp>
-      <p:sp>
-        <p:nvSpPr>
-          <p:cNvPr id="20" name="Text 18"/>
-          <p:cNvSpPr/>
-          <p:nvPr/>
-        </p:nvSpPr>
-        <p:spPr>
-          <a:xfrm>
-            <a:off x="548640" y="6473952"/>
-            <a:ext cx="8229600" cy="274320"/>
-          </a:xfrm>
-          <a:prstGeom prst="rect">
-            <a:avLst/>
-          </a:prstGeom>
-          <a:noFill/>
-          <a:ln/>
-        </p:spPr>
-        <p:txBody>
-          <a:bodyPr wrap="square" lIns="0" tIns="0" rIns="0" bIns="0" rtlCol="0" anchor="ctr"/>
-          <a:lstStyle/>
-          <a:p>
-            <a:pPr marL="0" indent="0">
-              <a:buNone/>
-            </a:pPr>
-            <a:r>
-              <a:rPr lang="en-US" sz="900" dirty="0">
-                <a:solidFill>
-                  <a:srgbClr val="AFAFAF"/>
-                </a:solidFill>
-                <a:latin typeface="Calibri" pitchFamily="34" charset="0"/>
-                <a:ea typeface="Calibri" pitchFamily="34" charset="-122"/>
-                <a:cs typeface="Calibri" pitchFamily="34" charset="-120"/>
-              </a:rPr>
-              <a:t>INNOLIFT VENTURES  ·  FULL STACK AI DEVELOPER PROGRAM  ·  PHASE 01 · DAY 5</a:t>
-            </a:r>
-            <a:endParaRPr lang="en-US" sz="900" dirty="0"/>
-          </a:p>
-        </p:txBody>
-      </p:sp>
-    </p:spTree>
-  </p:cSld>
-  <p:clrMapOvr>
-    <a:masterClrMapping/>
-  </p:clrMapOvr>
-</p:sld>
-</file>
-
-<file path=ppt/slides/slide11.xml><?xml version="1.0" encoding="utf-8"?>
-<p:sld xmlns:a="http://schemas.openxmlformats.org/drawingml/2006/main" xmlns:r="http://schemas.openxmlformats.org/officeDocument/2006/relationships" xmlns:p="http://schemas.openxmlformats.org/presentationml/2006/main">
-  <p:cSld name="Slide 11">
-    <p:bg>
-      <p:bgPr>
-        <a:solidFill>
-          <a:srgbClr val="1E2761"/>
-        </a:solidFill>
-        <a:effectLst/>
-      </p:bgPr>
-    </p:bg>
-    <p:spTree>
-      <p:nvGrpSpPr>
-        <p:cNvPr id="1" name=""/>
-        <p:cNvGrpSpPr/>
-        <p:nvPr/>
-      </p:nvGrpSpPr>
-      <p:grpSpPr>
-        <a:xfrm>
-          <a:off x="0" y="0"/>
-          <a:ext cx="0" cy="0"/>
-          <a:chOff x="0" y="0"/>
-          <a:chExt cx="0" cy="0"/>
-        </a:xfrm>
-      </p:grpSpPr>
-      <p:sp>
-        <p:nvSpPr>
-          <p:cNvPr id="2" name="Shape 0"/>
-          <p:cNvSpPr/>
-          <p:nvPr/>
-        </p:nvSpPr>
-        <p:spPr>
-          <a:xfrm>
-            <a:off x="-1828800" y="-1828800"/>
-            <a:ext cx="4572000" cy="4572000"/>
-          </a:xfrm>
-          <a:prstGeom prst="ellipse">
-            <a:avLst/>
-          </a:prstGeom>
-          <a:solidFill>
-            <a:srgbClr val="4950BC">
-              <a:alpha val="25000"/>
-            </a:srgbClr>
-          </a:solidFill>
-          <a:ln/>
-        </p:spPr>
-        <p:txBody>
-          <a:bodyPr/>
-          <a:lstStyle/>
-          <a:p>
-            <a:endParaRPr/>
-          </a:p>
-        </p:txBody>
-      </p:sp>
-      <p:sp>
-        <p:nvSpPr>
-          <p:cNvPr id="3" name="Shape 1"/>
-          <p:cNvSpPr/>
-          <p:nvPr/>
-        </p:nvSpPr>
-        <p:spPr>
-          <a:xfrm>
-            <a:off x="548640" y="457200"/>
-            <a:ext cx="2377440" cy="347472"/>
-          </a:xfrm>
-          <a:prstGeom prst="roundRect">
-            <a:avLst>
-              <a:gd name="adj" fmla="val 21053"/>
-            </a:avLst>
-          </a:prstGeom>
-          <a:solidFill>
-            <a:srgbClr val="E8912B"/>
-          </a:solidFill>
-          <a:ln/>
-        </p:spPr>
-        <p:txBody>
-          <a:bodyPr/>
-          <a:lstStyle/>
-          <a:p>
-            <a:endParaRPr/>
-          </a:p>
-        </p:txBody>
-      </p:sp>
-      <p:sp>
-        <p:nvSpPr>
-          <p:cNvPr id="4" name="Text 2"/>
-          <p:cNvSpPr/>
-          <p:nvPr/>
-        </p:nvSpPr>
-        <p:spPr>
-          <a:xfrm>
-            <a:off x="548640" y="457200"/>
-            <a:ext cx="2377440" cy="347472"/>
-          </a:xfrm>
-          <a:prstGeom prst="rect">
-            <a:avLst/>
-          </a:prstGeom>
-          <a:noFill/>
-          <a:ln/>
-        </p:spPr>
-        <p:txBody>
-          <a:bodyPr wrap="square" lIns="0" tIns="0" rIns="0" bIns="0" rtlCol="0" anchor="ctr"/>
-          <a:lstStyle/>
-          <a:p>
-            <a:pPr marL="0" indent="0" algn="ctr">
-              <a:buNone/>
-            </a:pPr>
-            <a:r>
-              <a:rPr lang="en-US" sz="1200" b="1" dirty="0">
-                <a:solidFill>
-                  <a:srgbClr val="1E2761"/>
-                </a:solidFill>
-                <a:latin typeface="Calibri" pitchFamily="34" charset="0"/>
-                <a:ea typeface="Calibri" pitchFamily="34" charset="-122"/>
-                <a:cs typeface="Calibri" pitchFamily="34" charset="-120"/>
-              </a:rPr>
-              <a:t>GOAL FOR TODAY</a:t>
-            </a:r>
-            <a:endParaRPr lang="en-US" sz="1200" dirty="0"/>
-          </a:p>
-        </p:txBody>
-      </p:sp>
-      <p:sp>
-        <p:nvSpPr>
-          <p:cNvPr id="5" name="Text 3"/>
-          <p:cNvSpPr/>
-          <p:nvPr/>
-        </p:nvSpPr>
-        <p:spPr>
-          <a:xfrm>
-            <a:off x="548640" y="1051560"/>
-            <a:ext cx="10515600" cy="822960"/>
-          </a:xfrm>
-          <a:prstGeom prst="rect">
-            <a:avLst/>
-          </a:prstGeom>
-          <a:noFill/>
-          <a:ln/>
-        </p:spPr>
-        <p:txBody>
-          <a:bodyPr wrap="square" lIns="0" tIns="0" rIns="0" bIns="0" rtlCol="0" anchor="ctr"/>
-          <a:lstStyle/>
-          <a:p>
-            <a:pPr marL="0" indent="0">
-              <a:buNone/>
-            </a:pPr>
-            <a:r>
-              <a:rPr lang="en-US" sz="2700" b="1" dirty="0">
-                <a:solidFill>
-                  <a:srgbClr val="FFFFFF"/>
-                </a:solidFill>
-                <a:latin typeface="Calibri" pitchFamily="34" charset="0"/>
-                <a:ea typeface="Calibri" pitchFamily="34" charset="-122"/>
-                <a:cs typeface="Calibri" pitchFamily="34" charset="-120"/>
-              </a:rPr>
-              <a:t>FitTrack Analytics — a Real Fitness Report</a:t>
-            </a:r>
-            <a:endParaRPr lang="en-US" sz="2700" dirty="0"/>
-          </a:p>
-        </p:txBody>
-      </p:sp>
-      <p:sp>
-        <p:nvSpPr>
-          <p:cNvPr id="6" name="Shape 4"/>
-          <p:cNvSpPr/>
-          <p:nvPr/>
-        </p:nvSpPr>
-        <p:spPr>
-          <a:xfrm>
-            <a:off x="548640" y="2103120"/>
-            <a:ext cx="6766560" cy="3931920"/>
-          </a:xfrm>
-          <a:prstGeom prst="roundRect">
-            <a:avLst>
-              <a:gd name="adj" fmla="val 1395"/>
-            </a:avLst>
-          </a:prstGeom>
-          <a:solidFill>
-            <a:srgbClr val="1E1E2E"/>
-          </a:solidFill>
-          <a:ln/>
-          <a:effectLst>
-            <a:outerShdw blurRad="101600" dist="38100" dir="5400000" algn="bl" rotWithShape="0">
-              <a:srgbClr val="000000">
-                <a:alpha val="18000"/>
-              </a:srgbClr>
-            </a:outerShdw>
-          </a:effectLst>
-        </p:spPr>
-        <p:txBody>
-          <a:bodyPr/>
-          <a:lstStyle/>
-          <a:p>
-            <a:endParaRPr/>
-          </a:p>
-        </p:txBody>
-      </p:sp>
-      <p:sp>
-        <p:nvSpPr>
-          <p:cNvPr id="7" name="Shape 5"/>
-          <p:cNvSpPr/>
-          <p:nvPr/>
-        </p:nvSpPr>
-        <p:spPr>
-          <a:xfrm>
-            <a:off x="713232" y="2249424"/>
-            <a:ext cx="109728" cy="109728"/>
-          </a:xfrm>
-          <a:prstGeom prst="ellipse">
-            <a:avLst/>
-          </a:prstGeom>
-          <a:solidFill>
-            <a:srgbClr val="FF5F56"/>
-          </a:solidFill>
-          <a:ln/>
-        </p:spPr>
-        <p:txBody>
-          <a:bodyPr/>
-          <a:lstStyle/>
-          <a:p>
-            <a:endParaRPr/>
-          </a:p>
-        </p:txBody>
-      </p:sp>
-      <p:sp>
-        <p:nvSpPr>
-          <p:cNvPr id="8" name="Shape 6"/>
-          <p:cNvSpPr/>
-          <p:nvPr/>
-        </p:nvSpPr>
-        <p:spPr>
-          <a:xfrm>
-            <a:off x="914400" y="2249424"/>
-            <a:ext cx="109728" cy="109728"/>
-          </a:xfrm>
-          <a:prstGeom prst="ellipse">
-            <a:avLst/>
-          </a:prstGeom>
-          <a:solidFill>
-            <a:srgbClr val="FFBD2E"/>
-          </a:solidFill>
-          <a:ln/>
-        </p:spPr>
-        <p:txBody>
-          <a:bodyPr/>
-          <a:lstStyle/>
-          <a:p>
-            <a:endParaRPr/>
-          </a:p>
-        </p:txBody>
-      </p:sp>
-      <p:sp>
-        <p:nvSpPr>
-          <p:cNvPr id="9" name="Shape 7"/>
-          <p:cNvSpPr/>
-          <p:nvPr/>
-        </p:nvSpPr>
-        <p:spPr>
-          <a:xfrm>
-            <a:off x="1115568" y="2249424"/>
-            <a:ext cx="109728" cy="109728"/>
-          </a:xfrm>
-          <a:prstGeom prst="ellipse">
-            <a:avLst/>
-          </a:prstGeom>
-          <a:solidFill>
-            <a:srgbClr val="27C93F"/>
-          </a:solidFill>
-          <a:ln/>
-        </p:spPr>
-        <p:txBody>
-          <a:bodyPr/>
-          <a:lstStyle/>
-          <a:p>
-            <a:endParaRPr/>
-          </a:p>
-        </p:txBody>
-      </p:sp>
-      <p:sp>
-        <p:nvSpPr>
-          <p:cNvPr id="10" name="Text 8"/>
-          <p:cNvSpPr/>
-          <p:nvPr/>
-        </p:nvSpPr>
-        <p:spPr>
-          <a:xfrm>
-            <a:off x="822960" y="2487168"/>
-            <a:ext cx="6217920" cy="384048"/>
-          </a:xfrm>
-          <a:prstGeom prst="rect">
-            <a:avLst/>
-          </a:prstGeom>
-          <a:noFill/>
-          <a:ln/>
-        </p:spPr>
-        <p:txBody>
-          <a:bodyPr wrap="square" lIns="0" tIns="0" rIns="0" bIns="0" rtlCol="0" anchor="ctr"/>
-          <a:lstStyle/>
-          <a:p>
-            <a:pPr marL="0" indent="0">
-              <a:buNone/>
-            </a:pPr>
-            <a:r>
-              <a:rPr lang="en-US" sz="1250" dirty="0">
-                <a:solidFill>
-                  <a:srgbClr val="8A8FA3"/>
-                </a:solidFill>
-                <a:latin typeface="Consolas" pitchFamily="34" charset="0"/>
-                <a:ea typeface="Consolas" pitchFamily="34" charset="-122"/>
-                <a:cs typeface="Consolas" pitchFamily="34" charset="-120"/>
-              </a:rPr>
-              <a:t>$ </a:t>
-            </a:r>
-            <a:r>
-              <a:rPr lang="en-US" sz="1250" dirty="0">
-                <a:solidFill>
-                  <a:srgbClr val="E4E4EE"/>
-                </a:solidFill>
-                <a:latin typeface="Consolas" pitchFamily="34" charset="0"/>
-                <a:ea typeface="Consolas" pitchFamily="34" charset="-122"/>
-                <a:cs typeface="Consolas" pitchFamily="34" charset="-120"/>
-              </a:rPr>
-              <a:t>python fittrack_analytics.py</a:t>
-            </a:r>
-            <a:endParaRPr lang="en-US" sz="1250" dirty="0"/>
-          </a:p>
-        </p:txBody>
-      </p:sp>
-      <p:sp>
-        <p:nvSpPr>
-          <p:cNvPr id="11" name="Text 9"/>
-          <p:cNvSpPr/>
-          <p:nvPr/>
-        </p:nvSpPr>
-        <p:spPr>
-          <a:xfrm>
-            <a:off x="822960" y="2871216"/>
-            <a:ext cx="6217920" cy="384048"/>
-          </a:xfrm>
-          <a:prstGeom prst="rect">
-            <a:avLst/>
-          </a:prstGeom>
-          <a:noFill/>
-          <a:ln/>
-        </p:spPr>
-        <p:txBody>
-          <a:bodyPr wrap="square" lIns="0" tIns="0" rIns="0" bIns="0" rtlCol="0" anchor="ctr"/>
-          <a:lstStyle/>
-          <a:p>
-            <a:pPr marL="0" indent="0">
-              <a:buNone/>
-            </a:pPr>
-            <a:endParaRPr lang="en-US" sz="1250" dirty="0"/>
-          </a:p>
-        </p:txBody>
-      </p:sp>
-      <p:sp>
-        <p:nvSpPr>
-          <p:cNvPr id="12" name="Text 10"/>
-          <p:cNvSpPr/>
-          <p:nvPr/>
-        </p:nvSpPr>
-        <p:spPr>
-          <a:xfrm>
-            <a:off x="822960" y="3255264"/>
-            <a:ext cx="6217920" cy="384048"/>
-          </a:xfrm>
-          <a:prstGeom prst="rect">
-            <a:avLst/>
-          </a:prstGeom>
-          <a:noFill/>
-          <a:ln/>
-        </p:spPr>
-        <p:txBody>
-          <a:bodyPr wrap="square" lIns="0" tIns="0" rIns="0" bIns="0" rtlCol="0" anchor="ctr"/>
-          <a:lstStyle/>
-          <a:p>
-            <a:pPr marL="0" indent="0">
-              <a:buNone/>
-            </a:pPr>
-            <a:r>
-              <a:rPr lang="en-US" sz="1250" dirty="0">
-                <a:solidFill>
-                  <a:srgbClr val="7FB4FF"/>
-                </a:solidFill>
-                <a:latin typeface="Consolas" pitchFamily="34" charset="0"/>
-                <a:ea typeface="Consolas" pitchFamily="34" charset="-122"/>
-                <a:cs typeface="Consolas" pitchFamily="34" charset="-120"/>
-              </a:rPr>
-              <a:t>===== FITTRACK WEEKLY REPORT =====</a:t>
-            </a:r>
-            <a:endParaRPr lang="en-US" sz="1250" dirty="0"/>
-          </a:p>
-        </p:txBody>
-      </p:sp>
-      <p:sp>
-        <p:nvSpPr>
-          <p:cNvPr id="13" name="Text 11"/>
-          <p:cNvSpPr/>
-          <p:nvPr/>
-        </p:nvSpPr>
-        <p:spPr>
-          <a:xfrm>
-            <a:off x="822960" y="3639312"/>
-            <a:ext cx="6217920" cy="384048"/>
-          </a:xfrm>
-          <a:prstGeom prst="rect">
-            <a:avLst/>
-          </a:prstGeom>
-          <a:noFill/>
-          <a:ln/>
-        </p:spPr>
-        <p:txBody>
-          <a:bodyPr wrap="square" lIns="0" tIns="0" rIns="0" bIns="0" rtlCol="0" anchor="ctr"/>
-          <a:lstStyle/>
-          <a:p>
-            <a:pPr marL="0" indent="0">
-              <a:buNone/>
-            </a:pPr>
-            <a:r>
-              <a:rPr lang="en-US" sz="1250" dirty="0">
-                <a:solidFill>
-                  <a:srgbClr val="F2C978"/>
-                </a:solidFill>
-                <a:latin typeface="Consolas" pitchFamily="34" charset="0"/>
-                <a:ea typeface="Consolas" pitchFamily="34" charset="-122"/>
-                <a:cs typeface="Consolas" pitchFamily="34" charset="-120"/>
-              </a:rPr>
-              <a:t>Monday       | steps: 8500 | activity: 0.72</a:t>
-            </a:r>
-            <a:endParaRPr lang="en-US" sz="1250" dirty="0"/>
-          </a:p>
-        </p:txBody>
-      </p:sp>
-      <p:sp>
-        <p:nvSpPr>
-          <p:cNvPr id="14" name="Text 12"/>
-          <p:cNvSpPr/>
-          <p:nvPr/>
-        </p:nvSpPr>
-        <p:spPr>
-          <a:xfrm>
-            <a:off x="822960" y="4023360"/>
-            <a:ext cx="6217920" cy="384048"/>
-          </a:xfrm>
-          <a:prstGeom prst="rect">
-            <a:avLst/>
-          </a:prstGeom>
-          <a:noFill/>
-          <a:ln/>
-        </p:spPr>
-        <p:txBody>
-          <a:bodyPr wrap="square" lIns="0" tIns="0" rIns="0" bIns="0" rtlCol="0" anchor="ctr"/>
-          <a:lstStyle/>
-          <a:p>
-            <a:pPr marL="0" indent="0">
-              <a:buNone/>
-            </a:pPr>
-            <a:r>
-              <a:rPr lang="en-US" sz="1250" dirty="0">
-                <a:solidFill>
-                  <a:srgbClr val="F2C978"/>
-                </a:solidFill>
-                <a:latin typeface="Consolas" pitchFamily="34" charset="0"/>
-                <a:ea typeface="Consolas" pitchFamily="34" charset="-122"/>
-                <a:cs typeface="Consolas" pitchFamily="34" charset="-120"/>
-              </a:rPr>
-              <a:t>Tuesday      | steps: 6200 | activity: 0.00</a:t>
-            </a:r>
-            <a:endParaRPr lang="en-US" sz="1250" dirty="0"/>
-          </a:p>
-        </p:txBody>
-      </p:sp>
-      <p:sp>
-        <p:nvSpPr>
-          <p:cNvPr id="15" name="Text 13"/>
-          <p:cNvSpPr/>
-          <p:nvPr/>
-        </p:nvSpPr>
-        <p:spPr>
-          <a:xfrm>
-            <a:off x="822960" y="4407408"/>
-            <a:ext cx="6217920" cy="384048"/>
-          </a:xfrm>
-          <a:prstGeom prst="rect">
-            <a:avLst/>
-          </a:prstGeom>
-          <a:noFill/>
-          <a:ln/>
-        </p:spPr>
-        <p:txBody>
-          <a:bodyPr wrap="square" lIns="0" tIns="0" rIns="0" bIns="0" rtlCol="0" anchor="ctr"/>
-          <a:lstStyle/>
-          <a:p>
-            <a:pPr marL="0" indent="0">
-              <a:buNone/>
-            </a:pPr>
-            <a:r>
-              <a:rPr lang="en-US" sz="1250" dirty="0">
-                <a:solidFill>
-                  <a:srgbClr val="F2C978"/>
-                </a:solidFill>
-                <a:latin typeface="Consolas" pitchFamily="34" charset="0"/>
-                <a:ea typeface="Consolas" pitchFamily="34" charset="-122"/>
-                <a:cs typeface="Consolas" pitchFamily="34" charset="-120"/>
-              </a:rPr>
-              <a:t>Wednesday    | steps: 9100 | activity: 1.00</a:t>
-            </a:r>
-            <a:endParaRPr lang="en-US" sz="1250" dirty="0"/>
-          </a:p>
-        </p:txBody>
-      </p:sp>
-      <p:sp>
-        <p:nvSpPr>
-          <p:cNvPr id="16" name="Text 14"/>
-          <p:cNvSpPr/>
-          <p:nvPr/>
-        </p:nvSpPr>
-        <p:spPr>
-          <a:xfrm>
-            <a:off x="822960" y="4791456"/>
-            <a:ext cx="6217920" cy="384048"/>
-          </a:xfrm>
-          <a:prstGeom prst="rect">
-            <a:avLst/>
-          </a:prstGeom>
-          <a:noFill/>
-          <a:ln/>
-        </p:spPr>
-        <p:txBody>
-          <a:bodyPr wrap="square" lIns="0" tIns="0" rIns="0" bIns="0" rtlCol="0" anchor="ctr"/>
-          <a:lstStyle/>
-          <a:p>
-            <a:pPr marL="0" indent="0">
-              <a:buNone/>
-            </a:pPr>
-            <a:r>
-              <a:rPr lang="en-US" sz="1250" dirty="0">
-                <a:solidFill>
-                  <a:srgbClr val="7FB4FF"/>
-                </a:solidFill>
-                <a:latin typeface="Consolas" pitchFamily="34" charset="0"/>
-                <a:ea typeface="Consolas" pitchFamily="34" charset="-122"/>
-                <a:cs typeface="Consolas" pitchFamily="34" charset="-120"/>
-              </a:rPr>
-              <a:t>========================================</a:t>
-            </a:r>
-            <a:endParaRPr lang="en-US" sz="1250" dirty="0"/>
-          </a:p>
-        </p:txBody>
-      </p:sp>
-      <p:sp>
-        <p:nvSpPr>
-          <p:cNvPr id="17" name="Text 15"/>
-          <p:cNvSpPr/>
-          <p:nvPr/>
-        </p:nvSpPr>
-        <p:spPr>
-          <a:xfrm>
-            <a:off x="822960" y="5175504"/>
-            <a:ext cx="6217920" cy="384048"/>
-          </a:xfrm>
-          <a:prstGeom prst="rect">
-            <a:avLst/>
-          </a:prstGeom>
-          <a:noFill/>
-          <a:ln/>
-        </p:spPr>
-        <p:txBody>
-          <a:bodyPr wrap="square" lIns="0" tIns="0" rIns="0" bIns="0" rtlCol="0" anchor="ctr"/>
-          <a:lstStyle/>
-          <a:p>
-            <a:pPr marL="0" indent="0">
-              <a:buNone/>
-            </a:pPr>
-            <a:r>
-              <a:rPr lang="en-US" sz="1250" dirty="0">
-                <a:solidFill>
-                  <a:srgbClr val="E4E4EE"/>
-                </a:solidFill>
-                <a:latin typeface="Consolas" pitchFamily="34" charset="0"/>
-                <a:ea typeface="Consolas" pitchFamily="34" charset="-122"/>
-                <a:cs typeface="Consolas" pitchFamily="34" charset="-120"/>
-              </a:rPr>
-              <a:t>Class average: </a:t>
-            </a:r>
-            <a:r>
-              <a:rPr lang="en-US" sz="1250" dirty="0">
-                <a:solidFill>
-                  <a:srgbClr val="F2C978"/>
-                </a:solidFill>
-                <a:latin typeface="Consolas" pitchFamily="34" charset="0"/>
-                <a:ea typeface="Consolas" pitchFamily="34" charset="-122"/>
-                <a:cs typeface="Consolas" pitchFamily="34" charset="-120"/>
-              </a:rPr>
-              <a:t>56.7</a:t>
-            </a:r>
-            <a:endParaRPr lang="en-US" sz="1250" dirty="0"/>
-          </a:p>
-        </p:txBody>
-      </p:sp>
-      <p:sp>
-        <p:nvSpPr>
-          <p:cNvPr id="18" name="Text 16"/>
-          <p:cNvSpPr/>
-          <p:nvPr/>
-        </p:nvSpPr>
-        <p:spPr>
-          <a:xfrm>
-            <a:off x="7452360" y="2286000"/>
-            <a:ext cx="4206240" cy="3200400"/>
-          </a:xfrm>
-          <a:prstGeom prst="rect">
-            <a:avLst/>
-          </a:prstGeom>
-          <a:noFill/>
-          <a:ln/>
-        </p:spPr>
-        <p:txBody>
-          <a:bodyPr wrap="square" lIns="0" tIns="0" rIns="0" bIns="0" rtlCol="0" anchor="t"/>
-          <a:lstStyle/>
-          <a:p>
-            <a:pPr marL="0" indent="0">
-              <a:lnSpc>
-                <a:spcPct val="125000"/>
-              </a:lnSpc>
-              <a:buNone/>
-            </a:pPr>
-            <a:r>
-              <a:rPr lang="en-US" sz="1500" b="1" dirty="0">
-                <a:solidFill>
-                  <a:srgbClr val="FFFFFF"/>
-                </a:solidFill>
-                <a:latin typeface="Calibri" pitchFamily="34" charset="0"/>
-                <a:ea typeface="Calibri" pitchFamily="34" charset="-122"/>
-                <a:cs typeface="Calibri" pitchFamily="34" charset="-120"/>
-              </a:rPr>
-              <a:t>Another brand new build. </a:t>
-            </a:r>
-            <a:r>
-              <a:rPr lang="en-US" sz="1500" dirty="0">
-                <a:solidFill>
-                  <a:srgbClr val="DADBF1"/>
-                </a:solidFill>
-                <a:latin typeface="Calibri" pitchFamily="34" charset="0"/>
-                <a:ea typeface="Calibri" pitchFamily="34" charset="-122"/>
-                <a:cs typeface="Calibri" pitchFamily="34" charset="-120"/>
-              </a:rPr>
-              <a:t>FitTrack Analytics reads your own steps_log.txt and ranks your whole week using NumPy.</a:t>
-            </a:r>
-            <a:endParaRPr lang="en-US" sz="1500" dirty="0"/>
-          </a:p>
-        </p:txBody>
-      </p:sp>
-      <p:sp>
-        <p:nvSpPr>
-          <p:cNvPr id="19" name="Text 17"/>
-          <p:cNvSpPr/>
-          <p:nvPr/>
-        </p:nvSpPr>
-        <p:spPr>
-          <a:xfrm>
-            <a:off x="548640" y="6473952"/>
-            <a:ext cx="8229600" cy="274320"/>
-          </a:xfrm>
-          <a:prstGeom prst="rect">
-            <a:avLst/>
-          </a:prstGeom>
-          <a:noFill/>
-          <a:ln/>
-        </p:spPr>
-        <p:txBody>
-          <a:bodyPr wrap="square" lIns="0" tIns="0" rIns="0" bIns="0" rtlCol="0" anchor="ctr"/>
-          <a:lstStyle/>
-          <a:p>
-            <a:pPr marL="0" indent="0">
-              <a:buNone/>
-            </a:pPr>
-            <a:r>
-              <a:rPr lang="en-US" sz="900" dirty="0">
-                <a:solidFill>
-                  <a:srgbClr val="AFAFAF"/>
-                </a:solidFill>
-                <a:latin typeface="Calibri" pitchFamily="34" charset="0"/>
-                <a:ea typeface="Calibri" pitchFamily="34" charset="-122"/>
-                <a:cs typeface="Calibri" pitchFamily="34" charset="-120"/>
-              </a:rPr>
-              <a:t>INNOLIFT VENTURES  ·  FULL STACK AI DEVELOPER PROGRAM  ·  PHASE 01 · DAY 5</a:t>
-            </a:r>
-            <a:endParaRPr lang="en-US" sz="900" dirty="0"/>
-          </a:p>
-        </p:txBody>
-      </p:sp>
-    </p:spTree>
-  </p:cSld>
-  <p:clrMapOvr>
-    <a:masterClrMapping/>
-  </p:clrMapOvr>
-</p:sld>
-</file>
-
-<file path=ppt/slides/slide12.xml><?xml version="1.0" encoding="utf-8"?>
 <p:sld xmlns:a="http://schemas.openxmlformats.org/drawingml/2006/main" xmlns:r="http://schemas.openxmlformats.org/officeDocument/2006/relationships" xmlns:p="http://schemas.openxmlformats.org/presentationml/2006/main">
   <p:cSld name="Slide 12">
     <p:bg>
@@ -5355,7 +3754,7 @@
 </p:sld>
 </file>
 
-<file path=ppt/slides/slide13.xml><?xml version="1.0" encoding="utf-8"?>
+<file path=ppt/slides/slide11.xml><?xml version="1.0" encoding="utf-8"?>
 <p:sld xmlns:a="http://schemas.openxmlformats.org/drawingml/2006/main" xmlns:r="http://schemas.openxmlformats.org/officeDocument/2006/relationships" xmlns:p="http://schemas.openxmlformats.org/presentationml/2006/main">
   <p:cSld name="Slide 13">
     <p:bg>
@@ -6265,7 +4664,7 @@
 </p:sld>
 </file>
 
-<file path=ppt/slides/slide14.xml><?xml version="1.0" encoding="utf-8"?>
+<file path=ppt/slides/slide12.xml><?xml version="1.0" encoding="utf-8"?>
 <p:sld xmlns:a="http://schemas.openxmlformats.org/drawingml/2006/main" xmlns:r="http://schemas.openxmlformats.org/officeDocument/2006/relationships" xmlns:p="http://schemas.openxmlformats.org/presentationml/2006/main">
   <p:cSld name="Slide 14">
     <p:bg>
@@ -7414,7 +5813,7 @@
 </p:sld>
 </file>
 
-<file path=ppt/slides/slide15.xml><?xml version="1.0" encoding="utf-8"?>
+<file path=ppt/slides/slide13.xml><?xml version="1.0" encoding="utf-8"?>
 <p:sld xmlns:a="http://schemas.openxmlformats.org/drawingml/2006/main" xmlns:r="http://schemas.openxmlformats.org/officeDocument/2006/relationships" xmlns:p="http://schemas.openxmlformats.org/presentationml/2006/main">
   <p:cSld name="Slide 15">
     <p:bg>
@@ -8473,7 +6872,7 @@
 </p:sld>
 </file>
 
-<file path=ppt/slides/slide16.xml><?xml version="1.0" encoding="utf-8"?>
+<file path=ppt/slides/slide14.xml><?xml version="1.0" encoding="utf-8"?>
 <p:sld xmlns:a="http://schemas.openxmlformats.org/drawingml/2006/main" xmlns:r="http://schemas.openxmlformats.org/officeDocument/2006/relationships" xmlns:p="http://schemas.openxmlformats.org/presentationml/2006/main">
   <p:cSld name="Slide 16">
     <p:bg>
@@ -9366,7 +7765,7 @@
 </p:sld>
 </file>
 
-<file path=ppt/slides/slide17.xml><?xml version="1.0" encoding="utf-8"?>
+<file path=ppt/slides/slide15.xml><?xml version="1.0" encoding="utf-8"?>
 <p:sld xmlns:a="http://schemas.openxmlformats.org/drawingml/2006/main" xmlns:r="http://schemas.openxmlformats.org/officeDocument/2006/relationships" xmlns:p="http://schemas.openxmlformats.org/presentationml/2006/main">
   <p:cSld name="Slide 17">
     <p:bg>
@@ -15003,11 +13402,11 @@
 
 <file path=ppt/slides/slide9.xml><?xml version="1.0" encoding="utf-8"?>
 <p:sld xmlns:a="http://schemas.openxmlformats.org/drawingml/2006/main" xmlns:r="http://schemas.openxmlformats.org/officeDocument/2006/relationships" xmlns:p="http://schemas.openxmlformats.org/presentationml/2006/main">
-  <p:cSld name="Slide 6">
+  <p:cSld name="Slide 11">
     <p:bg>
       <p:bgPr>
         <a:solidFill>
-          <a:srgbClr val="FFFFFF"/>
+          <a:srgbClr val="1E2761"/>
         </a:solidFill>
         <a:effectLst/>
       </p:bgPr>
@@ -15034,8 +13433,37 @@
         </p:nvSpPr>
         <p:spPr>
           <a:xfrm>
+            <a:off x="-1828800" y="-1828800"/>
+            <a:ext cx="4572000" cy="4572000"/>
+          </a:xfrm>
+          <a:prstGeom prst="ellipse">
+            <a:avLst/>
+          </a:prstGeom>
+          <a:solidFill>
+            <a:srgbClr val="4950BC">
+              <a:alpha val="25000"/>
+            </a:srgbClr>
+          </a:solidFill>
+          <a:ln/>
+        </p:spPr>
+        <p:txBody>
+          <a:bodyPr/>
+          <a:lstStyle/>
+          <a:p>
+            <a:endParaRPr/>
+          </a:p>
+        </p:txBody>
+      </p:sp>
+      <p:sp>
+        <p:nvSpPr>
+          <p:cNvPr id="3" name="Shape 1"/>
+          <p:cNvSpPr/>
+          <p:nvPr/>
+        </p:nvSpPr>
+        <p:spPr>
+          <a:xfrm>
             <a:off x="548640" y="457200"/>
-            <a:ext cx="3108960" cy="347472"/>
+            <a:ext cx="2377440" cy="347472"/>
           </a:xfrm>
           <a:prstGeom prst="roundRect">
             <a:avLst>
@@ -15043,7 +13471,7 @@
             </a:avLst>
           </a:prstGeom>
           <a:solidFill>
-            <a:srgbClr val="FCEEDA"/>
+            <a:srgbClr val="E8912B"/>
           </a:solidFill>
           <a:ln/>
         </p:spPr>
@@ -15057,14 +13485,14 @@
       </p:sp>
       <p:sp>
         <p:nvSpPr>
-          <p:cNvPr id="3" name="Text 1"/>
+          <p:cNvPr id="4" name="Text 2"/>
           <p:cNvSpPr/>
           <p:nvPr/>
         </p:nvSpPr>
         <p:spPr>
           <a:xfrm>
             <a:off x="548640" y="457200"/>
-            <a:ext cx="3108960" cy="347472"/>
+            <a:ext cx="2377440" cy="347472"/>
           </a:xfrm>
           <a:prstGeom prst="rect">
             <a:avLst/>
@@ -15082,13 +13510,13 @@
             <a:r>
               <a:rPr lang="en-US" sz="1200" b="1" dirty="0">
                 <a:solidFill>
-                  <a:srgbClr val="E8912B"/>
+                  <a:srgbClr val="1E2761"/>
                 </a:solidFill>
                 <a:latin typeface="Calibri" pitchFamily="34" charset="0"/>
                 <a:ea typeface="Calibri" pitchFamily="34" charset="-122"/>
                 <a:cs typeface="Calibri" pitchFamily="34" charset="-120"/>
               </a:rPr>
-              <a:t>QUICK PRACTICE · ROUND 1</a:t>
+              <a:t>GOAL FOR TODAY</a:t>
             </a:r>
             <a:endParaRPr lang="en-US" sz="1200" dirty="0"/>
           </a:p>
@@ -15096,597 +13524,539 @@
       </p:sp>
       <p:sp>
         <p:nvSpPr>
-          <p:cNvPr id="4" name="Text 2"/>
-          <p:cNvSpPr/>
-          <p:nvPr/>
-        </p:nvSpPr>
-        <p:spPr>
-          <a:xfrm>
-            <a:off x="548640" y="960120"/>
-            <a:ext cx="11091672" cy="731520"/>
-          </a:xfrm>
-          <a:prstGeom prst="rect">
-            <a:avLst/>
-          </a:prstGeom>
-          <a:noFill/>
-          <a:ln/>
-        </p:spPr>
-        <p:txBody>
-          <a:bodyPr wrap="square" lIns="0" tIns="0" rIns="0" bIns="0" rtlCol="0" anchor="ctr"/>
-          <a:lstStyle/>
-          <a:p>
-            <a:pPr marL="0" indent="0">
-              <a:buNone/>
-            </a:pPr>
-            <a:r>
-              <a:rPr lang="en-US" sz="2800" b="1" dirty="0">
-                <a:solidFill>
-                  <a:srgbClr val="1E2761"/>
+          <p:cNvPr id="5" name="Text 3"/>
+          <p:cNvSpPr/>
+          <p:nvPr/>
+        </p:nvSpPr>
+        <p:spPr>
+          <a:xfrm>
+            <a:off x="548640" y="1051560"/>
+            <a:ext cx="10515600" cy="822960"/>
+          </a:xfrm>
+          <a:prstGeom prst="rect">
+            <a:avLst/>
+          </a:prstGeom>
+          <a:noFill/>
+          <a:ln/>
+        </p:spPr>
+        <p:txBody>
+          <a:bodyPr wrap="square" lIns="0" tIns="0" rIns="0" bIns="0" rtlCol="0" anchor="ctr"/>
+          <a:lstStyle/>
+          <a:p>
+            <a:pPr marL="0" indent="0">
+              <a:buNone/>
+            </a:pPr>
+            <a:r>
+              <a:rPr lang="en-US" sz="2700" b="1" dirty="0">
+                <a:solidFill>
+                  <a:srgbClr val="FFFFFF"/>
                 </a:solidFill>
                 <a:latin typeface="Calibri" pitchFamily="34" charset="0"/>
                 <a:ea typeface="Calibri" pitchFamily="34" charset="-122"/>
                 <a:cs typeface="Calibri" pitchFamily="34" charset="-120"/>
               </a:rPr>
-              <a:t>Try It Yourself: Array Basics</a:t>
-            </a:r>
-            <a:endParaRPr lang="en-US" sz="2800" dirty="0"/>
-          </a:p>
-        </p:txBody>
-      </p:sp>
-      <p:sp>
-        <p:nvSpPr>
-          <p:cNvPr id="5" name="Text 3"/>
-          <p:cNvSpPr/>
-          <p:nvPr/>
-        </p:nvSpPr>
-        <p:spPr>
-          <a:xfrm>
-            <a:off x="548640" y="1600200"/>
-            <a:ext cx="9692640" cy="365760"/>
-          </a:xfrm>
-          <a:prstGeom prst="rect">
-            <a:avLst/>
-          </a:prstGeom>
-          <a:noFill/>
-          <a:ln/>
-        </p:spPr>
-        <p:txBody>
-          <a:bodyPr wrap="square" lIns="0" tIns="0" rIns="0" bIns="0" rtlCol="0" anchor="ctr"/>
-          <a:lstStyle/>
-          <a:p>
-            <a:pPr marL="0" indent="0">
-              <a:buNone/>
-            </a:pPr>
-            <a:r>
-              <a:rPr lang="en-US" sz="1400" dirty="0">
-                <a:solidFill>
-                  <a:srgbClr val="6B6B6B"/>
+              <a:t>FitTrack Analytics — a Real Fitness Report</a:t>
+            </a:r>
+            <a:endParaRPr lang="en-US" sz="2700" dirty="0"/>
+          </a:p>
+        </p:txBody>
+      </p:sp>
+      <p:sp>
+        <p:nvSpPr>
+          <p:cNvPr id="6" name="Shape 4"/>
+          <p:cNvSpPr/>
+          <p:nvPr/>
+        </p:nvSpPr>
+        <p:spPr>
+          <a:xfrm>
+            <a:off x="548640" y="2103120"/>
+            <a:ext cx="6766560" cy="3931920"/>
+          </a:xfrm>
+          <a:prstGeom prst="roundRect">
+            <a:avLst>
+              <a:gd name="adj" fmla="val 1395"/>
+            </a:avLst>
+          </a:prstGeom>
+          <a:solidFill>
+            <a:srgbClr val="1E1E2E"/>
+          </a:solidFill>
+          <a:ln/>
+          <a:effectLst>
+            <a:outerShdw blurRad="101600" dist="38100" dir="5400000" algn="bl" rotWithShape="0">
+              <a:srgbClr val="000000">
+                <a:alpha val="18000"/>
+              </a:srgbClr>
+            </a:outerShdw>
+          </a:effectLst>
+        </p:spPr>
+        <p:txBody>
+          <a:bodyPr/>
+          <a:lstStyle/>
+          <a:p>
+            <a:endParaRPr/>
+          </a:p>
+        </p:txBody>
+      </p:sp>
+      <p:sp>
+        <p:nvSpPr>
+          <p:cNvPr id="7" name="Shape 5"/>
+          <p:cNvSpPr/>
+          <p:nvPr/>
+        </p:nvSpPr>
+        <p:spPr>
+          <a:xfrm>
+            <a:off x="713232" y="2249424"/>
+            <a:ext cx="109728" cy="109728"/>
+          </a:xfrm>
+          <a:prstGeom prst="ellipse">
+            <a:avLst/>
+          </a:prstGeom>
+          <a:solidFill>
+            <a:srgbClr val="FF5F56"/>
+          </a:solidFill>
+          <a:ln/>
+        </p:spPr>
+        <p:txBody>
+          <a:bodyPr/>
+          <a:lstStyle/>
+          <a:p>
+            <a:endParaRPr/>
+          </a:p>
+        </p:txBody>
+      </p:sp>
+      <p:sp>
+        <p:nvSpPr>
+          <p:cNvPr id="8" name="Shape 6"/>
+          <p:cNvSpPr/>
+          <p:nvPr/>
+        </p:nvSpPr>
+        <p:spPr>
+          <a:xfrm>
+            <a:off x="914400" y="2249424"/>
+            <a:ext cx="109728" cy="109728"/>
+          </a:xfrm>
+          <a:prstGeom prst="ellipse">
+            <a:avLst/>
+          </a:prstGeom>
+          <a:solidFill>
+            <a:srgbClr val="FFBD2E"/>
+          </a:solidFill>
+          <a:ln/>
+        </p:spPr>
+        <p:txBody>
+          <a:bodyPr/>
+          <a:lstStyle/>
+          <a:p>
+            <a:endParaRPr/>
+          </a:p>
+        </p:txBody>
+      </p:sp>
+      <p:sp>
+        <p:nvSpPr>
+          <p:cNvPr id="9" name="Shape 7"/>
+          <p:cNvSpPr/>
+          <p:nvPr/>
+        </p:nvSpPr>
+        <p:spPr>
+          <a:xfrm>
+            <a:off x="1115568" y="2249424"/>
+            <a:ext cx="109728" cy="109728"/>
+          </a:xfrm>
+          <a:prstGeom prst="ellipse">
+            <a:avLst/>
+          </a:prstGeom>
+          <a:solidFill>
+            <a:srgbClr val="27C93F"/>
+          </a:solidFill>
+          <a:ln/>
+        </p:spPr>
+        <p:txBody>
+          <a:bodyPr/>
+          <a:lstStyle/>
+          <a:p>
+            <a:endParaRPr/>
+          </a:p>
+        </p:txBody>
+      </p:sp>
+      <p:sp>
+        <p:nvSpPr>
+          <p:cNvPr id="10" name="Text 8"/>
+          <p:cNvSpPr/>
+          <p:nvPr/>
+        </p:nvSpPr>
+        <p:spPr>
+          <a:xfrm>
+            <a:off x="822960" y="2487168"/>
+            <a:ext cx="6217920" cy="384048"/>
+          </a:xfrm>
+          <a:prstGeom prst="rect">
+            <a:avLst/>
+          </a:prstGeom>
+          <a:noFill/>
+          <a:ln/>
+        </p:spPr>
+        <p:txBody>
+          <a:bodyPr wrap="square" lIns="0" tIns="0" rIns="0" bIns="0" rtlCol="0" anchor="ctr"/>
+          <a:lstStyle/>
+          <a:p>
+            <a:pPr marL="0" indent="0">
+              <a:buNone/>
+            </a:pPr>
+            <a:r>
+              <a:rPr lang="en-US" sz="1250" dirty="0">
+                <a:solidFill>
+                  <a:srgbClr val="8A8FA3"/>
+                </a:solidFill>
+                <a:latin typeface="Consolas" pitchFamily="34" charset="0"/>
+                <a:ea typeface="Consolas" pitchFamily="34" charset="-122"/>
+                <a:cs typeface="Consolas" pitchFamily="34" charset="-120"/>
+              </a:rPr>
+              <a:t>$ </a:t>
+            </a:r>
+            <a:r>
+              <a:rPr lang="en-US" sz="1250" dirty="0">
+                <a:solidFill>
+                  <a:srgbClr val="E4E4EE"/>
+                </a:solidFill>
+                <a:latin typeface="Consolas" pitchFamily="34" charset="0"/>
+                <a:ea typeface="Consolas" pitchFamily="34" charset="-122"/>
+                <a:cs typeface="Consolas" pitchFamily="34" charset="-120"/>
+              </a:rPr>
+              <a:t>python fittrack_analytics.py</a:t>
+            </a:r>
+            <a:endParaRPr lang="en-US" sz="1250" dirty="0"/>
+          </a:p>
+        </p:txBody>
+      </p:sp>
+      <p:sp>
+        <p:nvSpPr>
+          <p:cNvPr id="11" name="Text 9"/>
+          <p:cNvSpPr/>
+          <p:nvPr/>
+        </p:nvSpPr>
+        <p:spPr>
+          <a:xfrm>
+            <a:off x="822960" y="2871216"/>
+            <a:ext cx="6217920" cy="384048"/>
+          </a:xfrm>
+          <a:prstGeom prst="rect">
+            <a:avLst/>
+          </a:prstGeom>
+          <a:noFill/>
+          <a:ln/>
+        </p:spPr>
+        <p:txBody>
+          <a:bodyPr wrap="square" lIns="0" tIns="0" rIns="0" bIns="0" rtlCol="0" anchor="ctr"/>
+          <a:lstStyle/>
+          <a:p>
+            <a:pPr marL="0" indent="0">
+              <a:buNone/>
+            </a:pPr>
+            <a:endParaRPr lang="en-US" sz="1250" dirty="0"/>
+          </a:p>
+        </p:txBody>
+      </p:sp>
+      <p:sp>
+        <p:nvSpPr>
+          <p:cNvPr id="12" name="Text 10"/>
+          <p:cNvSpPr/>
+          <p:nvPr/>
+        </p:nvSpPr>
+        <p:spPr>
+          <a:xfrm>
+            <a:off x="822960" y="3255264"/>
+            <a:ext cx="6217920" cy="384048"/>
+          </a:xfrm>
+          <a:prstGeom prst="rect">
+            <a:avLst/>
+          </a:prstGeom>
+          <a:noFill/>
+          <a:ln/>
+        </p:spPr>
+        <p:txBody>
+          <a:bodyPr wrap="square" lIns="0" tIns="0" rIns="0" bIns="0" rtlCol="0" anchor="ctr"/>
+          <a:lstStyle/>
+          <a:p>
+            <a:pPr marL="0" indent="0">
+              <a:buNone/>
+            </a:pPr>
+            <a:r>
+              <a:rPr lang="en-US" sz="1250" dirty="0">
+                <a:solidFill>
+                  <a:srgbClr val="7FB4FF"/>
+                </a:solidFill>
+                <a:latin typeface="Consolas" pitchFamily="34" charset="0"/>
+                <a:ea typeface="Consolas" pitchFamily="34" charset="-122"/>
+                <a:cs typeface="Consolas" pitchFamily="34" charset="-120"/>
+              </a:rPr>
+              <a:t>===== FITTRACK WEEKLY REPORT =====</a:t>
+            </a:r>
+            <a:endParaRPr lang="en-US" sz="1250" dirty="0"/>
+          </a:p>
+        </p:txBody>
+      </p:sp>
+      <p:sp>
+        <p:nvSpPr>
+          <p:cNvPr id="13" name="Text 11"/>
+          <p:cNvSpPr/>
+          <p:nvPr/>
+        </p:nvSpPr>
+        <p:spPr>
+          <a:xfrm>
+            <a:off x="822960" y="3639312"/>
+            <a:ext cx="6217920" cy="384048"/>
+          </a:xfrm>
+          <a:prstGeom prst="rect">
+            <a:avLst/>
+          </a:prstGeom>
+          <a:noFill/>
+          <a:ln/>
+        </p:spPr>
+        <p:txBody>
+          <a:bodyPr wrap="square" lIns="0" tIns="0" rIns="0" bIns="0" rtlCol="0" anchor="ctr"/>
+          <a:lstStyle/>
+          <a:p>
+            <a:pPr marL="0" indent="0">
+              <a:buNone/>
+            </a:pPr>
+            <a:r>
+              <a:rPr lang="en-US" sz="1250" dirty="0">
+                <a:solidFill>
+                  <a:srgbClr val="F2C978"/>
+                </a:solidFill>
+                <a:latin typeface="Consolas" pitchFamily="34" charset="0"/>
+                <a:ea typeface="Consolas" pitchFamily="34" charset="-122"/>
+                <a:cs typeface="Consolas" pitchFamily="34" charset="-120"/>
+              </a:rPr>
+              <a:t>Monday       | steps: 8500 | activity: 0.72</a:t>
+            </a:r>
+            <a:endParaRPr lang="en-US" sz="1250" dirty="0"/>
+          </a:p>
+        </p:txBody>
+      </p:sp>
+      <p:sp>
+        <p:nvSpPr>
+          <p:cNvPr id="14" name="Text 12"/>
+          <p:cNvSpPr/>
+          <p:nvPr/>
+        </p:nvSpPr>
+        <p:spPr>
+          <a:xfrm>
+            <a:off x="822960" y="4023360"/>
+            <a:ext cx="6217920" cy="384048"/>
+          </a:xfrm>
+          <a:prstGeom prst="rect">
+            <a:avLst/>
+          </a:prstGeom>
+          <a:noFill/>
+          <a:ln/>
+        </p:spPr>
+        <p:txBody>
+          <a:bodyPr wrap="square" lIns="0" tIns="0" rIns="0" bIns="0" rtlCol="0" anchor="ctr"/>
+          <a:lstStyle/>
+          <a:p>
+            <a:pPr marL="0" indent="0">
+              <a:buNone/>
+            </a:pPr>
+            <a:r>
+              <a:rPr lang="en-US" sz="1250" dirty="0">
+                <a:solidFill>
+                  <a:srgbClr val="F2C978"/>
+                </a:solidFill>
+                <a:latin typeface="Consolas" pitchFamily="34" charset="0"/>
+                <a:ea typeface="Consolas" pitchFamily="34" charset="-122"/>
+                <a:cs typeface="Consolas" pitchFamily="34" charset="-120"/>
+              </a:rPr>
+              <a:t>Tuesday      | steps: 6200 | activity: 0.00</a:t>
+            </a:r>
+            <a:endParaRPr lang="en-US" sz="1250" dirty="0"/>
+          </a:p>
+        </p:txBody>
+      </p:sp>
+      <p:sp>
+        <p:nvSpPr>
+          <p:cNvPr id="15" name="Text 13"/>
+          <p:cNvSpPr/>
+          <p:nvPr/>
+        </p:nvSpPr>
+        <p:spPr>
+          <a:xfrm>
+            <a:off x="822960" y="4407408"/>
+            <a:ext cx="6217920" cy="384048"/>
+          </a:xfrm>
+          <a:prstGeom prst="rect">
+            <a:avLst/>
+          </a:prstGeom>
+          <a:noFill/>
+          <a:ln/>
+        </p:spPr>
+        <p:txBody>
+          <a:bodyPr wrap="square" lIns="0" tIns="0" rIns="0" bIns="0" rtlCol="0" anchor="ctr"/>
+          <a:lstStyle/>
+          <a:p>
+            <a:pPr marL="0" indent="0">
+              <a:buNone/>
+            </a:pPr>
+            <a:r>
+              <a:rPr lang="en-US" sz="1250" dirty="0">
+                <a:solidFill>
+                  <a:srgbClr val="F2C978"/>
+                </a:solidFill>
+                <a:latin typeface="Consolas" pitchFamily="34" charset="0"/>
+                <a:ea typeface="Consolas" pitchFamily="34" charset="-122"/>
+                <a:cs typeface="Consolas" pitchFamily="34" charset="-120"/>
+              </a:rPr>
+              <a:t>Wednesday    | steps: 9100 | activity: 1.00</a:t>
+            </a:r>
+            <a:endParaRPr lang="en-US" sz="1250" dirty="0"/>
+          </a:p>
+        </p:txBody>
+      </p:sp>
+      <p:sp>
+        <p:nvSpPr>
+          <p:cNvPr id="16" name="Text 14"/>
+          <p:cNvSpPr/>
+          <p:nvPr/>
+        </p:nvSpPr>
+        <p:spPr>
+          <a:xfrm>
+            <a:off x="822960" y="4791456"/>
+            <a:ext cx="6217920" cy="384048"/>
+          </a:xfrm>
+          <a:prstGeom prst="rect">
+            <a:avLst/>
+          </a:prstGeom>
+          <a:noFill/>
+          <a:ln/>
+        </p:spPr>
+        <p:txBody>
+          <a:bodyPr wrap="square" lIns="0" tIns="0" rIns="0" bIns="0" rtlCol="0" anchor="ctr"/>
+          <a:lstStyle/>
+          <a:p>
+            <a:pPr marL="0" indent="0">
+              <a:buNone/>
+            </a:pPr>
+            <a:r>
+              <a:rPr lang="en-US" sz="1250" dirty="0">
+                <a:solidFill>
+                  <a:srgbClr val="7FB4FF"/>
+                </a:solidFill>
+                <a:latin typeface="Consolas" pitchFamily="34" charset="0"/>
+                <a:ea typeface="Consolas" pitchFamily="34" charset="-122"/>
+                <a:cs typeface="Consolas" pitchFamily="34" charset="-120"/>
+              </a:rPr>
+              <a:t>========================================</a:t>
+            </a:r>
+            <a:endParaRPr lang="en-US" sz="1250" dirty="0"/>
+          </a:p>
+        </p:txBody>
+      </p:sp>
+      <p:sp>
+        <p:nvSpPr>
+          <p:cNvPr id="17" name="Text 15"/>
+          <p:cNvSpPr/>
+          <p:nvPr/>
+        </p:nvSpPr>
+        <p:spPr>
+          <a:xfrm>
+            <a:off x="822960" y="5175504"/>
+            <a:ext cx="6217920" cy="384048"/>
+          </a:xfrm>
+          <a:prstGeom prst="rect">
+            <a:avLst/>
+          </a:prstGeom>
+          <a:noFill/>
+          <a:ln/>
+        </p:spPr>
+        <p:txBody>
+          <a:bodyPr wrap="square" lIns="0" tIns="0" rIns="0" bIns="0" rtlCol="0" anchor="ctr"/>
+          <a:lstStyle/>
+          <a:p>
+            <a:pPr marL="0" indent="0">
+              <a:buNone/>
+            </a:pPr>
+            <a:r>
+              <a:rPr lang="en-US" sz="1250" dirty="0">
+                <a:solidFill>
+                  <a:srgbClr val="E4E4EE"/>
+                </a:solidFill>
+                <a:latin typeface="Consolas" pitchFamily="34" charset="0"/>
+                <a:ea typeface="Consolas" pitchFamily="34" charset="-122"/>
+                <a:cs typeface="Consolas" pitchFamily="34" charset="-120"/>
+              </a:rPr>
+              <a:t>Class average: </a:t>
+            </a:r>
+            <a:r>
+              <a:rPr lang="en-US" sz="1250" dirty="0">
+                <a:solidFill>
+                  <a:srgbClr val="F2C978"/>
+                </a:solidFill>
+                <a:latin typeface="Consolas" pitchFamily="34" charset="0"/>
+                <a:ea typeface="Consolas" pitchFamily="34" charset="-122"/>
+                <a:cs typeface="Consolas" pitchFamily="34" charset="-120"/>
+              </a:rPr>
+              <a:t>56.7</a:t>
+            </a:r>
+            <a:endParaRPr lang="en-US" sz="1250" dirty="0"/>
+          </a:p>
+        </p:txBody>
+      </p:sp>
+      <p:sp>
+        <p:nvSpPr>
+          <p:cNvPr id="18" name="Text 16"/>
+          <p:cNvSpPr/>
+          <p:nvPr/>
+        </p:nvSpPr>
+        <p:spPr>
+          <a:xfrm>
+            <a:off x="7452360" y="2286000"/>
+            <a:ext cx="4206240" cy="3200400"/>
+          </a:xfrm>
+          <a:prstGeom prst="rect">
+            <a:avLst/>
+          </a:prstGeom>
+          <a:noFill/>
+          <a:ln/>
+        </p:spPr>
+        <p:txBody>
+          <a:bodyPr wrap="square" lIns="0" tIns="0" rIns="0" bIns="0" rtlCol="0" anchor="t"/>
+          <a:lstStyle/>
+          <a:p>
+            <a:pPr marL="0" indent="0">
+              <a:lnSpc>
+                <a:spcPct val="125000"/>
+              </a:lnSpc>
+              <a:buNone/>
+            </a:pPr>
+            <a:r>
+              <a:rPr lang="en-US" sz="1500" b="1" dirty="0">
+                <a:solidFill>
+                  <a:srgbClr val="FFFFFF"/>
                 </a:solidFill>
                 <a:latin typeface="Calibri" pitchFamily="34" charset="0"/>
                 <a:ea typeface="Calibri" pitchFamily="34" charset="-122"/>
                 <a:cs typeface="Calibri" pitchFamily="34" charset="-120"/>
               </a:rPr>
-              <a:t>Work through this on your own, at your own pace — no need to wait for anyone.</a:t>
-            </a:r>
-            <a:endParaRPr lang="en-US" sz="1400" dirty="0"/>
-          </a:p>
-        </p:txBody>
-      </p:sp>
-      <p:sp>
-        <p:nvSpPr>
-          <p:cNvPr id="6" name="Shape 4"/>
-          <p:cNvSpPr/>
-          <p:nvPr/>
-        </p:nvSpPr>
-        <p:spPr>
-          <a:xfrm>
-            <a:off x="548640" y="2103120"/>
-            <a:ext cx="1371600" cy="457200"/>
-          </a:xfrm>
-          <a:prstGeom prst="roundRect">
-            <a:avLst>
-              <a:gd name="adj" fmla="val 50000"/>
-            </a:avLst>
-          </a:prstGeom>
-          <a:solidFill>
-            <a:srgbClr val="DADBF1"/>
-          </a:solidFill>
-          <a:ln/>
-        </p:spPr>
-        <p:txBody>
-          <a:bodyPr/>
-          <a:lstStyle/>
-          <a:p>
-            <a:endParaRPr/>
-          </a:p>
-        </p:txBody>
-      </p:sp>
-      <p:sp>
-        <p:nvSpPr>
-          <p:cNvPr id="7" name="Text 5"/>
-          <p:cNvSpPr/>
-          <p:nvPr/>
-        </p:nvSpPr>
-        <p:spPr>
-          <a:xfrm>
-            <a:off x="548640" y="2103120"/>
-            <a:ext cx="1371600" cy="457200"/>
-          </a:xfrm>
-          <a:prstGeom prst="rect">
-            <a:avLst/>
-          </a:prstGeom>
-          <a:noFill/>
-          <a:ln/>
-        </p:spPr>
-        <p:txBody>
-          <a:bodyPr wrap="square" lIns="0" tIns="0" rIns="0" bIns="0" rtlCol="0" anchor="ctr"/>
-          <a:lstStyle/>
-          <a:p>
-            <a:pPr marL="0" indent="0" algn="ctr">
-              <a:buNone/>
-            </a:pPr>
-            <a:r>
-              <a:rPr lang="en-US" sz="1200" b="1" dirty="0">
-                <a:solidFill>
-                  <a:srgbClr val="4950BC"/>
+              <a:t>Another brand new build. </a:t>
+            </a:r>
+            <a:r>
+              <a:rPr lang="en-US" sz="1500" dirty="0">
+                <a:solidFill>
+                  <a:srgbClr val="DADBF1"/>
                 </a:solidFill>
                 <a:latin typeface="Calibri" pitchFamily="34" charset="0"/>
                 <a:ea typeface="Calibri" pitchFamily="34" charset="-122"/>
                 <a:cs typeface="Calibri" pitchFamily="34" charset="-120"/>
               </a:rPr>
-              <a:t>⏱  5 min</a:t>
-            </a:r>
-            <a:endParaRPr lang="en-US" sz="1200" dirty="0"/>
-          </a:p>
-        </p:txBody>
-      </p:sp>
-      <p:sp>
-        <p:nvSpPr>
-          <p:cNvPr id="8" name="Text 6"/>
-          <p:cNvSpPr/>
-          <p:nvPr/>
-        </p:nvSpPr>
-        <p:spPr>
-          <a:xfrm>
-            <a:off x="2103120" y="2103120"/>
-            <a:ext cx="8686800" cy="457200"/>
-          </a:xfrm>
-          <a:prstGeom prst="rect">
-            <a:avLst/>
-          </a:prstGeom>
-          <a:noFill/>
-          <a:ln/>
-        </p:spPr>
-        <p:txBody>
-          <a:bodyPr wrap="square" lIns="0" tIns="0" rIns="0" bIns="0" rtlCol="0" anchor="ctr"/>
-          <a:lstStyle/>
-          <a:p>
-            <a:pPr marL="0" indent="0">
-              <a:buNone/>
-            </a:pPr>
-            <a:r>
-              <a:rPr lang="en-US" sz="1400" b="1" dirty="0">
-                <a:solidFill>
-                  <a:srgbClr val="272525"/>
-                </a:solidFill>
-                <a:latin typeface="Calibri" pitchFamily="34" charset="0"/>
-                <a:ea typeface="Calibri" pitchFamily="34" charset="-122"/>
-                <a:cs typeface="Calibri" pitchFamily="34" charset="-120"/>
-              </a:rPr>
-              <a:t>Task:  </a:t>
-            </a:r>
-            <a:r>
-              <a:rPr lang="en-US" sz="1400" dirty="0">
-                <a:solidFill>
-                  <a:srgbClr val="272525"/>
-                </a:solidFill>
-                <a:latin typeface="Calibri" pitchFamily="34" charset="0"/>
-                <a:ea typeface="Calibri" pitchFamily="34" charset="-122"/>
-                <a:cs typeface="Calibri" pitchFamily="34" charset="-120"/>
-              </a:rPr>
-              <a:t>Build and index a small NumPy array.</a:t>
-            </a:r>
-            <a:endParaRPr lang="en-US" sz="1400" dirty="0"/>
-          </a:p>
-        </p:txBody>
-      </p:sp>
-      <p:sp>
-        <p:nvSpPr>
-          <p:cNvPr id="9" name="Shape 7"/>
-          <p:cNvSpPr/>
-          <p:nvPr/>
-        </p:nvSpPr>
-        <p:spPr>
-          <a:xfrm>
-            <a:off x="548640" y="2834640"/>
-            <a:ext cx="365760" cy="365760"/>
-          </a:xfrm>
-          <a:prstGeom prst="ellipse">
-            <a:avLst/>
-          </a:prstGeom>
-          <a:solidFill>
-            <a:srgbClr val="E8912B"/>
-          </a:solidFill>
-          <a:ln/>
-        </p:spPr>
-        <p:txBody>
-          <a:bodyPr/>
-          <a:lstStyle/>
-          <a:p>
-            <a:endParaRPr/>
-          </a:p>
-        </p:txBody>
-      </p:sp>
-      <p:sp>
-        <p:nvSpPr>
-          <p:cNvPr id="10" name="Text 8"/>
-          <p:cNvSpPr/>
-          <p:nvPr/>
-        </p:nvSpPr>
-        <p:spPr>
-          <a:xfrm>
-            <a:off x="548640" y="2834640"/>
-            <a:ext cx="365760" cy="365760"/>
-          </a:xfrm>
-          <a:prstGeom prst="rect">
-            <a:avLst/>
-          </a:prstGeom>
-          <a:noFill/>
-          <a:ln/>
-        </p:spPr>
-        <p:txBody>
-          <a:bodyPr wrap="square" lIns="0" tIns="0" rIns="0" bIns="0" rtlCol="0" anchor="ctr"/>
-          <a:lstStyle/>
-          <a:p>
-            <a:pPr marL="0" indent="0" algn="ctr">
-              <a:buNone/>
-            </a:pPr>
-            <a:r>
-              <a:rPr lang="en-US" sz="1300" b="1" dirty="0">
-                <a:solidFill>
-                  <a:srgbClr val="FFFFFF"/>
-                </a:solidFill>
-                <a:latin typeface="Calibri" pitchFamily="34" charset="0"/>
-                <a:ea typeface="Calibri" pitchFamily="34" charset="-122"/>
-                <a:cs typeface="Calibri" pitchFamily="34" charset="-120"/>
-              </a:rPr>
-              <a:t>1</a:t>
-            </a:r>
-            <a:endParaRPr lang="en-US" sz="1300" dirty="0"/>
-          </a:p>
-        </p:txBody>
-      </p:sp>
-      <p:sp>
-        <p:nvSpPr>
-          <p:cNvPr id="11" name="Text 9"/>
-          <p:cNvSpPr/>
-          <p:nvPr/>
-        </p:nvSpPr>
-        <p:spPr>
-          <a:xfrm>
-            <a:off x="1097280" y="2788920"/>
-            <a:ext cx="10241280" cy="502920"/>
-          </a:xfrm>
-          <a:prstGeom prst="rect">
-            <a:avLst/>
-          </a:prstGeom>
-          <a:noFill/>
-          <a:ln/>
-        </p:spPr>
-        <p:txBody>
-          <a:bodyPr wrap="square" lIns="0" tIns="0" rIns="0" bIns="0" rtlCol="0" anchor="t"/>
-          <a:lstStyle/>
-          <a:p>
-            <a:pPr marL="0" indent="0">
-              <a:buNone/>
-            </a:pPr>
-            <a:r>
-              <a:rPr lang="en-US" sz="1300" dirty="0">
-                <a:solidFill>
-                  <a:srgbClr val="272525"/>
-                </a:solidFill>
-                <a:latin typeface="Calibri" pitchFamily="34" charset="0"/>
-                <a:ea typeface="Calibri" pitchFamily="34" charset="-122"/>
-                <a:cs typeface="Calibri" pitchFamily="34" charset="-120"/>
-              </a:rPr>
-              <a:t>Create array_warmup.py and build a NumPy array of 6 numbers of your choice.</a:t>
-            </a:r>
-            <a:endParaRPr lang="en-US" sz="1300" dirty="0"/>
-          </a:p>
-        </p:txBody>
-      </p:sp>
-      <p:sp>
-        <p:nvSpPr>
-          <p:cNvPr id="12" name="Shape 10"/>
-          <p:cNvSpPr/>
-          <p:nvPr/>
-        </p:nvSpPr>
-        <p:spPr>
-          <a:xfrm>
-            <a:off x="548640" y="3401568"/>
-            <a:ext cx="365760" cy="365760"/>
-          </a:xfrm>
-          <a:prstGeom prst="ellipse">
-            <a:avLst/>
-          </a:prstGeom>
-          <a:solidFill>
-            <a:srgbClr val="E8912B"/>
-          </a:solidFill>
-          <a:ln/>
-        </p:spPr>
-        <p:txBody>
-          <a:bodyPr/>
-          <a:lstStyle/>
-          <a:p>
-            <a:endParaRPr/>
-          </a:p>
-        </p:txBody>
-      </p:sp>
-      <p:sp>
-        <p:nvSpPr>
-          <p:cNvPr id="13" name="Text 11"/>
-          <p:cNvSpPr/>
-          <p:nvPr/>
-        </p:nvSpPr>
-        <p:spPr>
-          <a:xfrm>
-            <a:off x="548640" y="3401568"/>
-            <a:ext cx="365760" cy="365760"/>
-          </a:xfrm>
-          <a:prstGeom prst="rect">
-            <a:avLst/>
-          </a:prstGeom>
-          <a:noFill/>
-          <a:ln/>
-        </p:spPr>
-        <p:txBody>
-          <a:bodyPr wrap="square" lIns="0" tIns="0" rIns="0" bIns="0" rtlCol="0" anchor="ctr"/>
-          <a:lstStyle/>
-          <a:p>
-            <a:pPr marL="0" indent="0" algn="ctr">
-              <a:buNone/>
-            </a:pPr>
-            <a:r>
-              <a:rPr lang="en-US" sz="1300" b="1" dirty="0">
-                <a:solidFill>
-                  <a:srgbClr val="FFFFFF"/>
-                </a:solidFill>
-                <a:latin typeface="Calibri" pitchFamily="34" charset="0"/>
-                <a:ea typeface="Calibri" pitchFamily="34" charset="-122"/>
-                <a:cs typeface="Calibri" pitchFamily="34" charset="-120"/>
-              </a:rPr>
-              <a:t>2</a:t>
-            </a:r>
-            <a:endParaRPr lang="en-US" sz="1300" dirty="0"/>
-          </a:p>
-        </p:txBody>
-      </p:sp>
-      <p:sp>
-        <p:nvSpPr>
-          <p:cNvPr id="14" name="Text 12"/>
-          <p:cNvSpPr/>
-          <p:nvPr/>
-        </p:nvSpPr>
-        <p:spPr>
-          <a:xfrm>
-            <a:off x="1097280" y="3355848"/>
-            <a:ext cx="10241280" cy="502920"/>
-          </a:xfrm>
-          <a:prstGeom prst="rect">
-            <a:avLst/>
-          </a:prstGeom>
-          <a:noFill/>
-          <a:ln/>
-        </p:spPr>
-        <p:txBody>
-          <a:bodyPr wrap="square" lIns="0" tIns="0" rIns="0" bIns="0" rtlCol="0" anchor="t"/>
-          <a:lstStyle/>
-          <a:p>
-            <a:pPr marL="0" indent="0">
-              <a:buNone/>
-            </a:pPr>
-            <a:r>
-              <a:rPr lang="en-US" sz="1300" dirty="0">
-                <a:solidFill>
-                  <a:srgbClr val="272525"/>
-                </a:solidFill>
-                <a:latin typeface="Calibri" pitchFamily="34" charset="0"/>
-                <a:ea typeface="Calibri" pitchFamily="34" charset="-122"/>
-                <a:cs typeface="Calibri" pitchFamily="34" charset="-120"/>
-              </a:rPr>
-              <a:t>Print the first item, the last item, and a slice of the middle 2 items.</a:t>
-            </a:r>
-            <a:endParaRPr lang="en-US" sz="1300" dirty="0"/>
-          </a:p>
-        </p:txBody>
-      </p:sp>
-      <p:sp>
-        <p:nvSpPr>
-          <p:cNvPr id="15" name="Shape 13"/>
-          <p:cNvSpPr/>
-          <p:nvPr/>
-        </p:nvSpPr>
-        <p:spPr>
-          <a:xfrm>
-            <a:off x="548640" y="3968496"/>
-            <a:ext cx="365760" cy="365760"/>
-          </a:xfrm>
-          <a:prstGeom prst="ellipse">
-            <a:avLst/>
-          </a:prstGeom>
-          <a:solidFill>
-            <a:srgbClr val="E8912B"/>
-          </a:solidFill>
-          <a:ln/>
-        </p:spPr>
-        <p:txBody>
-          <a:bodyPr/>
-          <a:lstStyle/>
-          <a:p>
-            <a:endParaRPr/>
-          </a:p>
-        </p:txBody>
-      </p:sp>
-      <p:sp>
-        <p:nvSpPr>
-          <p:cNvPr id="16" name="Text 14"/>
-          <p:cNvSpPr/>
-          <p:nvPr/>
-        </p:nvSpPr>
-        <p:spPr>
-          <a:xfrm>
-            <a:off x="548640" y="3968496"/>
-            <a:ext cx="365760" cy="365760"/>
-          </a:xfrm>
-          <a:prstGeom prst="rect">
-            <a:avLst/>
-          </a:prstGeom>
-          <a:noFill/>
-          <a:ln/>
-        </p:spPr>
-        <p:txBody>
-          <a:bodyPr wrap="square" lIns="0" tIns="0" rIns="0" bIns="0" rtlCol="0" anchor="ctr"/>
-          <a:lstStyle/>
-          <a:p>
-            <a:pPr marL="0" indent="0" algn="ctr">
-              <a:buNone/>
-            </a:pPr>
-            <a:r>
-              <a:rPr lang="en-US" sz="1300" b="1" dirty="0">
-                <a:solidFill>
-                  <a:srgbClr val="FFFFFF"/>
-                </a:solidFill>
-                <a:latin typeface="Calibri" pitchFamily="34" charset="0"/>
-                <a:ea typeface="Calibri" pitchFamily="34" charset="-122"/>
-                <a:cs typeface="Calibri" pitchFamily="34" charset="-120"/>
-              </a:rPr>
-              <a:t>3</a:t>
-            </a:r>
-            <a:endParaRPr lang="en-US" sz="1300" dirty="0"/>
-          </a:p>
-        </p:txBody>
-      </p:sp>
-      <p:sp>
-        <p:nvSpPr>
-          <p:cNvPr id="17" name="Text 15"/>
-          <p:cNvSpPr/>
-          <p:nvPr/>
-        </p:nvSpPr>
-        <p:spPr>
-          <a:xfrm>
-            <a:off x="1097280" y="3922776"/>
-            <a:ext cx="10241280" cy="502920"/>
-          </a:xfrm>
-          <a:prstGeom prst="rect">
-            <a:avLst/>
-          </a:prstGeom>
-          <a:noFill/>
-          <a:ln/>
-        </p:spPr>
-        <p:txBody>
-          <a:bodyPr wrap="square" lIns="0" tIns="0" rIns="0" bIns="0" rtlCol="0" anchor="t"/>
-          <a:lstStyle/>
-          <a:p>
-            <a:pPr marL="0" indent="0">
-              <a:buNone/>
-            </a:pPr>
-            <a:r>
-              <a:rPr lang="en-US" sz="1300" dirty="0">
-                <a:solidFill>
-                  <a:srgbClr val="272525"/>
-                </a:solidFill>
-                <a:latin typeface="Calibri" pitchFamily="34" charset="0"/>
-                <a:ea typeface="Calibri" pitchFamily="34" charset="-122"/>
-                <a:cs typeface="Calibri" pitchFamily="34" charset="-120"/>
-              </a:rPr>
-              <a:t>Print the array's length using len() and confirm it matches what you expect.</a:t>
-            </a:r>
-            <a:endParaRPr lang="en-US" sz="1300" dirty="0"/>
-          </a:p>
-        </p:txBody>
-      </p:sp>
-      <p:sp>
-        <p:nvSpPr>
-          <p:cNvPr id="18" name="Shape 16"/>
-          <p:cNvSpPr/>
-          <p:nvPr/>
-        </p:nvSpPr>
-        <p:spPr>
-          <a:xfrm>
-            <a:off x="548640" y="4764024"/>
-            <a:ext cx="11091672" cy="731520"/>
-          </a:xfrm>
-          <a:prstGeom prst="roundRect">
-            <a:avLst>
-              <a:gd name="adj" fmla="val 10000"/>
-            </a:avLst>
-          </a:prstGeom>
-          <a:solidFill>
-            <a:srgbClr val="F5F5F7"/>
-          </a:solidFill>
-          <a:ln/>
-        </p:spPr>
-        <p:txBody>
-          <a:bodyPr/>
-          <a:lstStyle/>
-          <a:p>
-            <a:endParaRPr/>
+              <a:t>FitTrack Analytics reads your own steps_log.txt and ranks your whole week using NumPy.</a:t>
+            </a:r>
+            <a:endParaRPr lang="en-US" sz="1500" dirty="0"/>
           </a:p>
         </p:txBody>
       </p:sp>
       <p:sp>
         <p:nvSpPr>
           <p:cNvPr id="19" name="Text 17"/>
-          <p:cNvSpPr/>
-          <p:nvPr/>
-        </p:nvSpPr>
-        <p:spPr>
-          <a:xfrm>
-            <a:off x="822960" y="4764024"/>
-            <a:ext cx="10543032" cy="731520"/>
-          </a:xfrm>
-          <a:prstGeom prst="rect">
-            <a:avLst/>
-          </a:prstGeom>
-          <a:noFill/>
-          <a:ln/>
-        </p:spPr>
-        <p:txBody>
-          <a:bodyPr wrap="square" lIns="0" tIns="0" rIns="0" bIns="0" rtlCol="0" anchor="ctr"/>
-          <a:lstStyle/>
-          <a:p>
-            <a:pPr marL="0" indent="0">
-              <a:buNone/>
-            </a:pPr>
-            <a:r>
-              <a:rPr lang="en-US" sz="1250" b="1" dirty="0">
-                <a:solidFill>
-                  <a:srgbClr val="272525"/>
-                </a:solidFill>
-                <a:latin typeface="Calibri" pitchFamily="34" charset="0"/>
-                <a:ea typeface="Calibri" pitchFamily="34" charset="-122"/>
-                <a:cs typeface="Calibri" pitchFamily="34" charset="-120"/>
-              </a:rPr>
-              <a:t>💡 Hint:  </a:t>
-            </a:r>
-            <a:r>
-              <a:rPr lang="en-US" sz="1250" dirty="0">
-                <a:solidFill>
-                  <a:srgbClr val="6B6B6B"/>
-                </a:solidFill>
-                <a:latin typeface="Calibri" pitchFamily="34" charset="0"/>
-                <a:ea typeface="Calibri" pitchFamily="34" charset="-122"/>
-                <a:cs typeface="Calibri" pitchFamily="34" charset="-120"/>
-              </a:rPr>
-              <a:t>Negative indexing works here too — arr[-1] is always the last item, just like a list.</a:t>
-            </a:r>
-            <a:endParaRPr lang="en-US" sz="1250" dirty="0"/>
-          </a:p>
-        </p:txBody>
-      </p:sp>
-      <p:sp>
-        <p:nvSpPr>
-          <p:cNvPr id="20" name="Text 18"/>
           <p:cNvSpPr/>
           <p:nvPr/>
         </p:nvSpPr>

</xml_diff>